<commit_message>
Ngữ văn 10-12 Bài 1, 2: bổ sung video học liệu (đã kiểm tra liên kết) vào KHBD và slide
Co-Authored-By: Claude Opus 5.5 <noreply@anthropic.com>
</commit_message>
<xml_diff>
--- a/mon/ngu_van/slide/lop11/Slide_NGUVAN11_Bai2_CauTuVaHinhAnhTrongThoTruTinh_T12-22.pptx
+++ b/mon/ngu_van/slide/lop11/Slide_NGUVAN11_Bai2_CauTuVaHinhAnhTrongThoTruTinh_T12-22.pptx
@@ -36,6 +36,8 @@
     <p:sldId id="284" r:id="rId36"/>
     <p:sldId id="285" r:id="rId37"/>
     <p:sldId id="286" r:id="rId38"/>
+    <p:sldId id="287" r:id="rId39"/>
+    <p:sldId id="288" r:id="rId40"/>
   </p:sldIdLst>
   <p:sldSz cx="12191695" cy="6858000" type="screen4x3"/>
   <p:notesSz cx="6858000" cy="9144000"/>
@@ -602,7 +604,7 @@
           <a:lstStyle/>
           <a:p>
             <a:r>
-              <a:t>Slide ĐỀ BÀI – cho HS suy nghĩ, thảo luận (không chiếu lời giải). </a:t>
+              <a:t>Bấm vào đường link hoặc quét mã QR để mở video (cần Internet). </a:t>
             </a:r>
           </a:p>
         </p:txBody>
@@ -672,7 +674,7 @@
           <a:lstStyle/>
           <a:p>
             <a:r>
-              <a:t>Slide LỜI GIẢI – GV chốt sau khi HS trình bày. </a:t>
+              <a:t>Slide ĐỀ BÀI – cho HS suy nghĩ, thảo luận (không chiếu lời giải). </a:t>
             </a:r>
           </a:p>
         </p:txBody>
@@ -742,7 +744,7 @@
           <a:lstStyle/>
           <a:p>
             <a:r>
-              <a:t>Slide ĐỀ BÀI – cho HS suy nghĩ, thảo luận (không chiếu lời giải). </a:t>
+              <a:t>Slide LỜI GIẢI – GV chốt sau khi HS trình bày. </a:t>
             </a:r>
           </a:p>
         </p:txBody>
@@ -812,7 +814,7 @@
           <a:lstStyle/>
           <a:p>
             <a:r>
-              <a:t>Slide LỜI GIẢI – GV chốt sau khi HS trình bày. </a:t>
+              <a:t>Slide ĐỀ BÀI – cho HS suy nghĩ, thảo luận (không chiếu lời giải). </a:t>
             </a:r>
           </a:p>
         </p:txBody>
@@ -882,7 +884,7 @@
           <a:lstStyle/>
           <a:p>
             <a:r>
-              <a:t>Slide ĐỀ BÀI – cho HS suy nghĩ, thảo luận (không chiếu lời giải). </a:t>
+              <a:t>Slide LỜI GIẢI – GV chốt sau khi HS trình bày. </a:t>
             </a:r>
           </a:p>
         </p:txBody>
@@ -952,7 +954,7 @@
           <a:lstStyle/>
           <a:p>
             <a:r>
-              <a:t>Slide LỜI GIẢI – GV chốt sau khi HS trình bày. </a:t>
+              <a:t>Slide ĐỀ BÀI – cho HS suy nghĩ, thảo luận (không chiếu lời giải). </a:t>
             </a:r>
           </a:p>
         </p:txBody>
@@ -1022,7 +1024,7 @@
           <a:lstStyle/>
           <a:p>
             <a:r>
-              <a:t>Slide ĐỀ BÀI – cho HS suy nghĩ, thảo luận (không chiếu lời giải). </a:t>
+              <a:t>Slide LỜI GIẢI – GV chốt sau khi HS trình bày. </a:t>
             </a:r>
           </a:p>
         </p:txBody>
@@ -1092,7 +1094,7 @@
           <a:lstStyle/>
           <a:p>
             <a:r>
-              <a:t>Slide LỜI GIẢI – GV chốt sau khi HS trình bày. </a:t>
+              <a:t>Bấm vào đường link hoặc quét mã QR để mở video (cần Internet). </a:t>
             </a:r>
           </a:p>
         </p:txBody>
@@ -1398,6 +1400,146 @@
 </file>
 
 <file path=ppt/notesSlides/notesSlide21.xml><?xml version="1.0" encoding="utf-8"?>
+<p:notes xmlns:a="http://schemas.openxmlformats.org/drawingml/2006/main" xmlns:p="http://schemas.openxmlformats.org/presentationml/2006/main" xmlns:r="http://schemas.openxmlformats.org/officeDocument/2006/relationships">
+  <p:cSld>
+    <p:spTree>
+      <p:nvGrpSpPr>
+        <p:cNvPr id="1" name=""/>
+        <p:cNvGrpSpPr/>
+        <p:nvPr/>
+      </p:nvGrpSpPr>
+      <p:grpSpPr>
+        <a:xfrm>
+          <a:off x="0" y="0"/>
+          <a:ext cx="0" cy="0"/>
+          <a:chOff x="0" y="0"/>
+          <a:chExt cx="0" cy="0"/>
+        </a:xfrm>
+      </p:grpSpPr>
+      <p:sp>
+        <p:nvSpPr>
+          <p:cNvPr id="2" name="Slide Image Placeholder 1"/>
+          <p:cNvSpPr>
+            <a:spLocks noGrp="1"/>
+          </p:cNvSpPr>
+          <p:nvPr>
+            <p:ph type="sldImg" idx="2"/>
+          </p:nvPr>
+        </p:nvSpPr>
+        <p:spPr/>
+      </p:sp>
+      <p:sp>
+        <p:nvSpPr>
+          <p:cNvPr id="3" name="Notes Placeholder 2"/>
+          <p:cNvSpPr>
+            <a:spLocks noGrp="1"/>
+          </p:cNvSpPr>
+          <p:nvPr>
+            <p:ph type="body" idx="3" sz="quarter"/>
+          </p:nvPr>
+        </p:nvSpPr>
+        <p:spPr/>
+        <p:txBody>
+          <a:bodyPr/>
+          <a:lstStyle/>
+          <a:p>
+            <a:r>
+              <a:t>Slide LỜI GIẢI – GV chốt sau khi HS trình bày. </a:t>
+            </a:r>
+          </a:p>
+        </p:txBody>
+      </p:sp>
+      <p:sp>
+        <p:nvSpPr>
+          <p:cNvPr id="4" name="Slide Number Placeholder 3"/>
+          <p:cNvSpPr>
+            <a:spLocks noGrp="1"/>
+          </p:cNvSpPr>
+          <p:nvPr>
+            <p:ph type="sldNum" idx="5" sz="quarter"/>
+          </p:nvPr>
+        </p:nvSpPr>
+        <p:spPr/>
+      </p:sp>
+    </p:spTree>
+  </p:cSld>
+  <p:clrMapOvr>
+    <a:masterClrMapping/>
+  </p:clrMapOvr>
+</p:notes>
+</file>
+
+<file path=ppt/notesSlides/notesSlide22.xml><?xml version="1.0" encoding="utf-8"?>
+<p:notes xmlns:a="http://schemas.openxmlformats.org/drawingml/2006/main" xmlns:p="http://schemas.openxmlformats.org/presentationml/2006/main" xmlns:r="http://schemas.openxmlformats.org/officeDocument/2006/relationships">
+  <p:cSld>
+    <p:spTree>
+      <p:nvGrpSpPr>
+        <p:cNvPr id="1" name=""/>
+        <p:cNvGrpSpPr/>
+        <p:nvPr/>
+      </p:nvGrpSpPr>
+      <p:grpSpPr>
+        <a:xfrm>
+          <a:off x="0" y="0"/>
+          <a:ext cx="0" cy="0"/>
+          <a:chOff x="0" y="0"/>
+          <a:chExt cx="0" cy="0"/>
+        </a:xfrm>
+      </p:grpSpPr>
+      <p:sp>
+        <p:nvSpPr>
+          <p:cNvPr id="2" name="Slide Image Placeholder 1"/>
+          <p:cNvSpPr>
+            <a:spLocks noGrp="1"/>
+          </p:cNvSpPr>
+          <p:nvPr>
+            <p:ph type="sldImg" idx="2"/>
+          </p:nvPr>
+        </p:nvSpPr>
+        <p:spPr/>
+      </p:sp>
+      <p:sp>
+        <p:nvSpPr>
+          <p:cNvPr id="3" name="Notes Placeholder 2"/>
+          <p:cNvSpPr>
+            <a:spLocks noGrp="1"/>
+          </p:cNvSpPr>
+          <p:nvPr>
+            <p:ph type="body" idx="3" sz="quarter"/>
+          </p:nvPr>
+        </p:nvSpPr>
+        <p:spPr/>
+        <p:txBody>
+          <a:bodyPr/>
+          <a:lstStyle/>
+          <a:p>
+            <a:r>
+              <a:t>Slide ĐỀ BÀI – cho HS suy nghĩ, thảo luận (không chiếu lời giải). </a:t>
+            </a:r>
+          </a:p>
+        </p:txBody>
+      </p:sp>
+      <p:sp>
+        <p:nvSpPr>
+          <p:cNvPr id="4" name="Slide Number Placeholder 3"/>
+          <p:cNvSpPr>
+            <a:spLocks noGrp="1"/>
+          </p:cNvSpPr>
+          <p:nvPr>
+            <p:ph type="sldNum" idx="5" sz="quarter"/>
+          </p:nvPr>
+        </p:nvSpPr>
+        <p:spPr/>
+      </p:sp>
+    </p:spTree>
+  </p:cSld>
+  <p:clrMapOvr>
+    <a:masterClrMapping/>
+  </p:clrMapOvr>
+</p:notes>
+</file>
+
+<file path=ppt/notesSlides/notesSlide23.xml><?xml version="1.0" encoding="utf-8"?>
 <p:notes xmlns:a="http://schemas.openxmlformats.org/drawingml/2006/main" xmlns:p="http://schemas.openxmlformats.org/presentationml/2006/main" xmlns:r="http://schemas.openxmlformats.org/officeDocument/2006/relationships">
   <p:cSld>
     <p:spTree>
@@ -6333,14 +6475,14 @@
         </p:nvSpPr>
         <p:spPr>
           <a:xfrm>
-            <a:off x="10253167" y="457200"/>
-            <a:ext cx="1389888" cy="457200"/>
+            <a:off x="10408615" y="457200"/>
+            <a:ext cx="1234440" cy="457200"/>
           </a:xfrm>
           <a:prstGeom prst="roundRect">
             <a:avLst/>
           </a:prstGeom>
           <a:solidFill>
-            <a:srgbClr val="1E40AF"/>
+            <a:srgbClr val="991B1B"/>
           </a:solidFill>
           <a:ln>
             <a:noFill/>
@@ -6373,7 +6515,7 @@
                 </a:solidFill>
                 <a:latin typeface="Arial"/>
               </a:rPr>
-              <a:t>ĐỀ BÀI</a:t>
+              <a:t>VIDEO</a:t>
             </a:r>
           </a:p>
         </p:txBody>
@@ -6387,7 +6529,7 @@
         <p:spPr>
           <a:xfrm>
             <a:off x="731520" y="274320"/>
-            <a:ext cx="9582912" cy="868680"/>
+            <a:ext cx="9738360" cy="868680"/>
           </a:xfrm>
           <a:prstGeom prst="rect">
             <a:avLst/>
@@ -6407,7 +6549,7 @@
                 </a:solidFill>
                 <a:latin typeface="Arial"/>
               </a:rPr>
-              <a:t>NHAN ĐỀ, ĐỀ TỪ VÀ KHUNG CẢNH</a:t>
+              <a:t>VIDEO THAM KHẢO</a:t>
             </a:r>
           </a:p>
         </p:txBody>
@@ -6491,16 +6633,40 @@
           </a:p>
         </p:txBody>
       </p:sp>
-      <p:sp>
-        <p:nvSpPr>
-          <p:cNvPr id="7" name="TextBox 6"/>
+      <p:pic>
+        <p:nvPicPr>
+          <p:cNvPr id="7" name="Picture 6" descr="QR_video_zdVP4hMfcmk.png"/>
+          <p:cNvPicPr>
+            <a:picLocks noChangeAspect="1"/>
+          </p:cNvPicPr>
+          <p:nvPr/>
+        </p:nvPicPr>
+        <p:blipFill>
+          <a:blip r:embed="rId2"/>
+          <a:stretch>
+            <a:fillRect/>
+          </a:stretch>
+        </p:blipFill>
+        <p:spPr>
+          <a:xfrm>
+            <a:off x="8412480" y="1554480"/>
+            <a:ext cx="3108960" cy="3108960"/>
+          </a:xfrm>
+          <a:prstGeom prst="rect">
+            <a:avLst/>
+          </a:prstGeom>
+        </p:spPr>
+      </p:pic>
+      <p:sp>
+        <p:nvSpPr>
+          <p:cNvPr id="8" name="TextBox 7"/>
           <p:cNvSpPr txBox="1"/>
           <p:nvPr/>
         </p:nvSpPr>
         <p:spPr>
           <a:xfrm>
-            <a:off x="731520" y="1463040"/>
-            <a:ext cx="10789920" cy="3566160"/>
+            <a:off x="731520" y="1554480"/>
+            <a:ext cx="7498079" cy="4206240"/>
           </a:xfrm>
           <a:prstGeom prst="rect">
             <a:avLst/>
@@ -6525,94 +6691,61 @@
                 </a:solidFill>
                 <a:latin typeface="Calibri"/>
               </a:rPr>
-              <a:t>Cảm nhận về nhan đề Tràng giang? Nhan đề và đề từ liên quan thế nào với nội dung cảm xúc? Khung cảnh được “vẽ” ra có tính chất gì?</a:t>
-            </a:r>
-          </a:p>
-        </p:txBody>
-      </p:sp>
-      <p:sp>
-        <p:nvSpPr>
-          <p:cNvPr id="8" name="Rounded Rectangle 7"/>
-          <p:cNvSpPr/>
-          <p:nvPr/>
-        </p:nvSpPr>
-        <p:spPr>
-          <a:xfrm>
-            <a:off x="731520" y="5120640"/>
-            <a:ext cx="10789920" cy="693420"/>
-          </a:xfrm>
-          <a:prstGeom prst="roundRect">
-            <a:avLst>
-              <a:gd name="adj" fmla="val 8000"/>
-            </a:avLst>
-          </a:prstGeom>
-          <a:solidFill>
-            <a:srgbClr val="EFF4FF"/>
-          </a:solidFill>
-          <a:ln w="19050">
-            <a:solidFill>
-              <a:srgbClr val="1E40AF"/>
-            </a:solidFill>
-          </a:ln>
-          <a:effectLst/>
-        </p:spPr>
-        <p:style>
-          <a:lnRef idx="1">
-            <a:schemeClr val="accent1"/>
-          </a:lnRef>
-          <a:fillRef idx="3">
-            <a:schemeClr val="accent1"/>
-          </a:fillRef>
-          <a:effectRef idx="2">
-            <a:schemeClr val="accent1"/>
-          </a:effectRef>
-          <a:fontRef idx="minor">
-            <a:schemeClr val="lt1"/>
-          </a:fontRef>
-        </p:style>
-        <p:txBody>
-          <a:bodyPr rtlCol="0" anchor="ctr"/>
-          <a:lstStyle/>
-          <a:p>
-            <a:pPr algn="ctr"/>
-          </a:p>
-        </p:txBody>
-      </p:sp>
-      <p:sp>
-        <p:nvSpPr>
-          <p:cNvPr id="9" name="TextBox 8"/>
-          <p:cNvSpPr txBox="1"/>
-          <p:nvPr/>
-        </p:nvSpPr>
-        <p:spPr>
-          <a:xfrm>
-            <a:off x="914400" y="5120640"/>
-            <a:ext cx="10424160" cy="693420"/>
-          </a:xfrm>
-          <a:prstGeom prst="rect">
-            <a:avLst/>
-          </a:prstGeom>
-          <a:noFill/>
-        </p:spPr>
-        <p:txBody>
-          <a:bodyPr wrap="square" anchor="ctr" lIns="45720" rIns="45720">
-            <a:spAutoFit/>
-          </a:bodyPr>
-          <a:lstStyle/>
+              <a:t>🎬 Bài thơ Tràng giang – Huy Cận – Tô Kiều Ngân ngâm</a:t>
+            </a:r>
+          </a:p>
           <a:p>
             <a:pPr algn="l">
               <a:spcAft>
-                <a:spcPts val="400"/>
+                <a:spcPts val="800"/>
               </a:spcAft>
             </a:pPr>
             <a:r>
-              <a:rPr sz="2200" b="1">
-                <a:solidFill>
-                  <a:srgbClr val="1E40AF"/>
+              <a:rPr sz="2000">
+                <a:solidFill>
+                  <a:srgbClr val="64748B"/>
                 </a:solidFill>
                 <a:latin typeface="Calibri"/>
               </a:rPr>
-              <a:t>💡 Đề từ: “Bâng khuâng trời rộng nhớ sông dài”.</a:t>
+              <a:t>Kênh: Lê &amp; H</a:t>
+            </a:r>
+          </a:p>
+          <a:p>
+            <a:pPr algn="l" marL="365760" indent="-365760">
+              <a:spcAft>
+                <a:spcPts val="800"/>
+              </a:spcAft>
+              <a:buClr>
+                <a:srgbClr val="1E40AF"/>
+              </a:buClr>
+              <a:buFont typeface="Arial"/>
+              <a:buChar char="•"/>
+            </a:pPr>
+            <a:r>
+              <a:rPr sz="2000">
+                <a:solidFill>
+                  <a:srgbClr val="1E293B"/>
+                </a:solidFill>
+                <a:latin typeface="Calibri"/>
+              </a:rPr>
+              <a:t>Đọc diễn cảm Tràng giang</a:t>
+            </a:r>
+          </a:p>
+          <a:p>
+            <a:pPr algn="l">
+              <a:spcAft>
+                <a:spcPts val="800"/>
+              </a:spcAft>
+            </a:pPr>
+            <a:r>
+              <a:rPr sz="1600">
+                <a:solidFill>
+                  <a:srgbClr val="64748B"/>
+                </a:solidFill>
+                <a:latin typeface="Calibri"/>
+                <a:hlinkClick r:id="rId3"/>
+              </a:rPr>
+              <a:t>https://www.youtube.com/watch?v=zdVP4hMfcmk</a:t>
             </a:r>
           </a:p>
         </p:txBody>
@@ -6695,14 +6828,14 @@
         </p:nvSpPr>
         <p:spPr>
           <a:xfrm>
-            <a:off x="9942271" y="457200"/>
-            <a:ext cx="1700784" cy="457200"/>
+            <a:off x="10253167" y="457200"/>
+            <a:ext cx="1389888" cy="457200"/>
           </a:xfrm>
           <a:prstGeom prst="roundRect">
             <a:avLst/>
           </a:prstGeom>
           <a:solidFill>
-            <a:srgbClr val="991B1B"/>
+            <a:srgbClr val="1E40AF"/>
           </a:solidFill>
           <a:ln>
             <a:noFill/>
@@ -6735,7 +6868,7 @@
                 </a:solidFill>
                 <a:latin typeface="Arial"/>
               </a:rPr>
-              <a:t>LỜI GIẢI</a:t>
+              <a:t>ĐỀ BÀI</a:t>
             </a:r>
           </a:p>
         </p:txBody>
@@ -6749,7 +6882,7 @@
         <p:spPr>
           <a:xfrm>
             <a:off x="731520" y="274320"/>
-            <a:ext cx="9272016" cy="868680"/>
+            <a:ext cx="9582912" cy="868680"/>
           </a:xfrm>
           <a:prstGeom prst="rect">
             <a:avLst/>
@@ -6862,7 +6995,7 @@
         <p:spPr>
           <a:xfrm>
             <a:off x="731520" y="1463040"/>
-            <a:ext cx="10789920" cy="3474720"/>
+            <a:ext cx="10789920" cy="3566160"/>
           </a:xfrm>
           <a:prstGeom prst="rect">
             <a:avLst/>
@@ -6875,66 +7008,19 @@
           </a:bodyPr>
           <a:lstStyle/>
           <a:p>
-            <a:pPr algn="l" marL="365760" indent="-365760">
+            <a:pPr algn="l">
               <a:spcAft>
                 <a:spcPts val="800"/>
               </a:spcAft>
-              <a:buClr>
-                <a:srgbClr val="1E40AF"/>
-              </a:buClr>
-              <a:buFont typeface="Arial"/>
-              <a:buChar char="•"/>
             </a:pPr>
             <a:r>
-              <a:rPr sz="2300">
+              <a:rPr sz="2600" b="1">
                 <a:solidFill>
                   <a:srgbClr val="1E293B"/>
                 </a:solidFill>
                 <a:latin typeface="Calibri"/>
               </a:rPr>
-              <a:t>“Tràng giang”: âm Hán Việt, vần “ang” vang mở – dòng sông mang tầm vũ trụ.</a:t>
-            </a:r>
-          </a:p>
-          <a:p>
-            <a:pPr algn="l" marL="365760" indent="-365760">
-              <a:spcAft>
-                <a:spcPts val="800"/>
-              </a:spcAft>
-              <a:buClr>
-                <a:srgbClr val="1E40AF"/>
-              </a:buClr>
-              <a:buFont typeface="Arial"/>
-              <a:buChar char="•"/>
-            </a:pPr>
-            <a:r>
-              <a:rPr sz="2300">
-                <a:solidFill>
-                  <a:srgbClr val="1E293B"/>
-                </a:solidFill>
-                <a:latin typeface="Calibri"/>
-              </a:rPr>
-              <a:t>Đề từ gợi cảm xúc chủ đạo: bâng khuâng, nhớ nhung.</a:t>
-            </a:r>
-          </a:p>
-          <a:p>
-            <a:pPr algn="l" marL="365760" indent="-365760">
-              <a:spcAft>
-                <a:spcPts val="800"/>
-              </a:spcAft>
-              <a:buClr>
-                <a:srgbClr val="1E40AF"/>
-              </a:buClr>
-              <a:buFont typeface="Arial"/>
-              <a:buChar char="•"/>
-            </a:pPr>
-            <a:r>
-              <a:rPr sz="2300">
-                <a:solidFill>
-                  <a:srgbClr val="1E293B"/>
-                </a:solidFill>
-                <a:latin typeface="Calibri"/>
-              </a:rPr>
-              <a:t>Khung cảnh: mênh mông, hiu quạnh, vắng lặng, cổ kính.</a:t>
+              <a:t>Cảm nhận về nhan đề Tràng giang? Nhan đề và đề từ liên quan thế nào với nội dung cảm xúc? Khung cảnh được “vẽ” ra có tính chất gì?</a:t>
             </a:r>
           </a:p>
         </p:txBody>
@@ -6947,8 +7033,8 @@
         </p:nvSpPr>
         <p:spPr>
           <a:xfrm>
-            <a:off x="731520" y="5074920"/>
-            <a:ext cx="10789920" cy="731520"/>
+            <a:off x="731520" y="5120640"/>
+            <a:ext cx="10789920" cy="693420"/>
           </a:xfrm>
           <a:prstGeom prst="roundRect">
             <a:avLst>
@@ -6956,11 +7042,11 @@
             </a:avLst>
           </a:prstGeom>
           <a:solidFill>
-            <a:srgbClr val="FEF2F2"/>
+            <a:srgbClr val="EFF4FF"/>
           </a:solidFill>
           <a:ln w="19050">
             <a:solidFill>
-              <a:srgbClr val="991B1B"/>
+              <a:srgbClr val="1E40AF"/>
             </a:solidFill>
           </a:ln>
           <a:effectLst/>
@@ -6995,8 +7081,8 @@
         </p:nvSpPr>
         <p:spPr>
           <a:xfrm>
-            <a:off x="914400" y="5074920"/>
-            <a:ext cx="10424160" cy="731520"/>
+            <a:off x="914400" y="5120640"/>
+            <a:ext cx="10424160" cy="693420"/>
           </a:xfrm>
           <a:prstGeom prst="rect">
             <a:avLst/>
@@ -7015,13 +7101,13 @@
               </a:spcAft>
             </a:pPr>
             <a:r>
-              <a:rPr sz="2400" b="1">
-                <a:solidFill>
-                  <a:srgbClr val="991B1B"/>
+              <a:rPr sz="2200" b="1">
+                <a:solidFill>
+                  <a:srgbClr val="1E40AF"/>
                 </a:solidFill>
                 <a:latin typeface="Calibri"/>
               </a:rPr>
-              <a:t>Nỗi buồn của cái tôi trước không gian vô tận.</a:t>
+              <a:t>💡 Đề từ: “Bâng khuâng trời rộng nhớ sông dài”.</a:t>
             </a:r>
           </a:p>
         </p:txBody>
@@ -7104,14 +7190,14 @@
         </p:nvSpPr>
         <p:spPr>
           <a:xfrm>
-            <a:off x="10253167" y="457200"/>
-            <a:ext cx="1389888" cy="457200"/>
+            <a:off x="9942271" y="457200"/>
+            <a:ext cx="1700784" cy="457200"/>
           </a:xfrm>
           <a:prstGeom prst="roundRect">
             <a:avLst/>
           </a:prstGeom>
           <a:solidFill>
-            <a:srgbClr val="1E40AF"/>
+            <a:srgbClr val="991B1B"/>
           </a:solidFill>
           <a:ln>
             <a:noFill/>
@@ -7144,7 +7230,7 @@
                 </a:solidFill>
                 <a:latin typeface="Arial"/>
               </a:rPr>
-              <a:t>ĐỀ BÀI</a:t>
+              <a:t>LỜI GIẢI</a:t>
             </a:r>
           </a:p>
         </p:txBody>
@@ -7158,7 +7244,7 @@
         <p:spPr>
           <a:xfrm>
             <a:off x="731520" y="274320"/>
-            <a:ext cx="9582912" cy="868680"/>
+            <a:ext cx="9272016" cy="868680"/>
           </a:xfrm>
           <a:prstGeom prst="rect">
             <a:avLst/>
@@ -7178,7 +7264,7 @@
                 </a:solidFill>
                 <a:latin typeface="Arial"/>
               </a:rPr>
-              <a:t>CẤU TỨ VÀ SỰ TƯƠNG PHẢN</a:t>
+              <a:t>NHAN ĐỀ, ĐỀ TỪ VÀ KHUNG CẢNH</a:t>
             </a:r>
           </a:p>
         </p:txBody>
@@ -7271,7 +7357,7 @@
         <p:spPr>
           <a:xfrm>
             <a:off x="731520" y="1463040"/>
-            <a:ext cx="10789920" cy="3566160"/>
+            <a:ext cx="10789920" cy="3474720"/>
           </a:xfrm>
           <a:prstGeom prst="rect">
             <a:avLst/>
@@ -7284,19 +7370,66 @@
           </a:bodyPr>
           <a:lstStyle/>
           <a:p>
-            <a:pPr algn="l">
+            <a:pPr algn="l" marL="365760" indent="-365760">
               <a:spcAft>
                 <a:spcPts val="800"/>
               </a:spcAft>
+              <a:buClr>
+                <a:srgbClr val="1E40AF"/>
+              </a:buClr>
+              <a:buFont typeface="Arial"/>
+              <a:buChar char="•"/>
             </a:pPr>
             <a:r>
-              <a:rPr sz="2600" b="1">
+              <a:rPr sz="2300">
                 <a:solidFill>
                   <a:srgbClr val="1E293B"/>
                 </a:solidFill>
                 <a:latin typeface="Calibri"/>
               </a:rPr>
-              <a:t>Bài thơ được cấu tứ như thế nào? Chỉ ra sự tương phản giữa các hình ảnh trong khổ thứ hai và sự triển khai ở các khổ sau.</a:t>
+              <a:t>“Tràng giang”: âm Hán Việt, vần “ang” vang mở – dòng sông mang tầm vũ trụ.</a:t>
+            </a:r>
+          </a:p>
+          <a:p>
+            <a:pPr algn="l" marL="365760" indent="-365760">
+              <a:spcAft>
+                <a:spcPts val="800"/>
+              </a:spcAft>
+              <a:buClr>
+                <a:srgbClr val="1E40AF"/>
+              </a:buClr>
+              <a:buFont typeface="Arial"/>
+              <a:buChar char="•"/>
+            </a:pPr>
+            <a:r>
+              <a:rPr sz="2300">
+                <a:solidFill>
+                  <a:srgbClr val="1E293B"/>
+                </a:solidFill>
+                <a:latin typeface="Calibri"/>
+              </a:rPr>
+              <a:t>Đề từ gợi cảm xúc chủ đạo: bâng khuâng, nhớ nhung.</a:t>
+            </a:r>
+          </a:p>
+          <a:p>
+            <a:pPr algn="l" marL="365760" indent="-365760">
+              <a:spcAft>
+                <a:spcPts val="800"/>
+              </a:spcAft>
+              <a:buClr>
+                <a:srgbClr val="1E40AF"/>
+              </a:buClr>
+              <a:buFont typeface="Arial"/>
+              <a:buChar char="•"/>
+            </a:pPr>
+            <a:r>
+              <a:rPr sz="2300">
+                <a:solidFill>
+                  <a:srgbClr val="1E293B"/>
+                </a:solidFill>
+                <a:latin typeface="Calibri"/>
+              </a:rPr>
+              <a:t>Khung cảnh: mênh mông, hiu quạnh, vắng lặng, cổ kính.</a:t>
             </a:r>
           </a:p>
         </p:txBody>
@@ -7309,8 +7442,8 @@
         </p:nvSpPr>
         <p:spPr>
           <a:xfrm>
-            <a:off x="731520" y="5120640"/>
-            <a:ext cx="10789920" cy="693420"/>
+            <a:off x="731520" y="5074920"/>
+            <a:ext cx="10789920" cy="731520"/>
           </a:xfrm>
           <a:prstGeom prst="roundRect">
             <a:avLst>
@@ -7318,11 +7451,11 @@
             </a:avLst>
           </a:prstGeom>
           <a:solidFill>
-            <a:srgbClr val="EFF4FF"/>
+            <a:srgbClr val="FEF2F2"/>
           </a:solidFill>
           <a:ln w="19050">
             <a:solidFill>
-              <a:srgbClr val="1E40AF"/>
+              <a:srgbClr val="991B1B"/>
             </a:solidFill>
           </a:ln>
           <a:effectLst/>
@@ -7357,8 +7490,8 @@
         </p:nvSpPr>
         <p:spPr>
           <a:xfrm>
-            <a:off x="914400" y="5120640"/>
-            <a:ext cx="10424160" cy="693420"/>
+            <a:off x="914400" y="5074920"/>
+            <a:ext cx="10424160" cy="731520"/>
           </a:xfrm>
           <a:prstGeom prst="rect">
             <a:avLst/>
@@ -7377,13 +7510,13 @@
               </a:spcAft>
             </a:pPr>
             <a:r>
-              <a:rPr sz="2200" b="1">
-                <a:solidFill>
-                  <a:srgbClr val="1E40AF"/>
+              <a:rPr sz="2400" b="1">
+                <a:solidFill>
+                  <a:srgbClr val="991B1B"/>
                 </a:solidFill>
                 <a:latin typeface="Calibri"/>
               </a:rPr>
-              <a:t>💡 Cái gì nhỏ bé, cái gì rộng lớn?</a:t>
+              <a:t>Nỗi buồn của cái tôi trước không gian vô tận.</a:t>
             </a:r>
           </a:p>
         </p:txBody>
@@ -7466,14 +7599,14 @@
         </p:nvSpPr>
         <p:spPr>
           <a:xfrm>
-            <a:off x="9942271" y="457200"/>
-            <a:ext cx="1700784" cy="457200"/>
+            <a:off x="10253167" y="457200"/>
+            <a:ext cx="1389888" cy="457200"/>
           </a:xfrm>
           <a:prstGeom prst="roundRect">
             <a:avLst/>
           </a:prstGeom>
           <a:solidFill>
-            <a:srgbClr val="991B1B"/>
+            <a:srgbClr val="1E40AF"/>
           </a:solidFill>
           <a:ln>
             <a:noFill/>
@@ -7506,7 +7639,7 @@
                 </a:solidFill>
                 <a:latin typeface="Arial"/>
               </a:rPr>
-              <a:t>LỜI GIẢI</a:t>
+              <a:t>ĐỀ BÀI</a:t>
             </a:r>
           </a:p>
         </p:txBody>
@@ -7520,7 +7653,7 @@
         <p:spPr>
           <a:xfrm>
             <a:off x="731520" y="274320"/>
-            <a:ext cx="9272016" cy="868680"/>
+            <a:ext cx="9582912" cy="868680"/>
           </a:xfrm>
           <a:prstGeom prst="rect">
             <a:avLst/>
@@ -7633,7 +7766,7 @@
         <p:spPr>
           <a:xfrm>
             <a:off x="731520" y="1463040"/>
-            <a:ext cx="10789920" cy="3474720"/>
+            <a:ext cx="10789920" cy="3566160"/>
           </a:xfrm>
           <a:prstGeom prst="rect">
             <a:avLst/>
@@ -7646,66 +7779,19 @@
           </a:bodyPr>
           <a:lstStyle/>
           <a:p>
-            <a:pPr algn="l" marL="365760" indent="-365760">
+            <a:pPr algn="l">
               <a:spcAft>
                 <a:spcPts val="800"/>
               </a:spcAft>
-              <a:buClr>
-                <a:srgbClr val="1E40AF"/>
-              </a:buClr>
-              <a:buFont typeface="Arial"/>
-              <a:buChar char="•"/>
             </a:pPr>
             <a:r>
-              <a:rPr sz="2300">
+              <a:rPr sz="2600" b="1">
                 <a:solidFill>
                   <a:srgbClr val="1E293B"/>
                 </a:solidFill>
                 <a:latin typeface="Calibri"/>
               </a:rPr>
-              <a:t>Cấu tứ: vô hạn của vũ trụ ↔ hữu hạn, nhỏ bé của con người.</a:t>
-            </a:r>
-          </a:p>
-          <a:p>
-            <a:pPr algn="l" marL="365760" indent="-365760">
-              <a:spcAft>
-                <a:spcPts val="800"/>
-              </a:spcAft>
-              <a:buClr>
-                <a:srgbClr val="1E40AF"/>
-              </a:buClr>
-              <a:buFont typeface="Arial"/>
-              <a:buChar char="•"/>
-            </a:pPr>
-            <a:r>
-              <a:rPr sz="2300">
-                <a:solidFill>
-                  <a:srgbClr val="1E293B"/>
-                </a:solidFill>
-                <a:latin typeface="Calibri"/>
-              </a:rPr>
-              <a:t>Khổ 2: “lơ thơ cồn nhỏ” ↔ “sông dài, trời rộng”.</a:t>
-            </a:r>
-          </a:p>
-          <a:p>
-            <a:pPr algn="l" marL="365760" indent="-365760">
-              <a:spcAft>
-                <a:spcPts val="800"/>
-              </a:spcAft>
-              <a:buClr>
-                <a:srgbClr val="1E40AF"/>
-              </a:buClr>
-              <a:buFont typeface="Arial"/>
-              <a:buChar char="•"/>
-            </a:pPr>
-            <a:r>
-              <a:rPr sz="2300">
-                <a:solidFill>
-                  <a:srgbClr val="1E293B"/>
-                </a:solidFill>
-                <a:latin typeface="Calibri"/>
-              </a:rPr>
-              <a:t>Khổ 3: bèo dạt – không đò, không cầu; khổ 4: mây núi bạc – cánh chim nhỏ.</a:t>
+              <a:t>Bài thơ được cấu tứ như thế nào? Chỉ ra sự tương phản giữa các hình ảnh trong khổ thứ hai và sự triển khai ở các khổ sau.</a:t>
             </a:r>
           </a:p>
         </p:txBody>
@@ -7718,8 +7804,8 @@
         </p:nvSpPr>
         <p:spPr>
           <a:xfrm>
-            <a:off x="731520" y="5074920"/>
-            <a:ext cx="10789920" cy="731520"/>
+            <a:off x="731520" y="5120640"/>
+            <a:ext cx="10789920" cy="693420"/>
           </a:xfrm>
           <a:prstGeom prst="roundRect">
             <a:avLst>
@@ -7727,11 +7813,11 @@
             </a:avLst>
           </a:prstGeom>
           <a:solidFill>
-            <a:srgbClr val="FEF2F2"/>
+            <a:srgbClr val="EFF4FF"/>
           </a:solidFill>
           <a:ln w="19050">
             <a:solidFill>
-              <a:srgbClr val="991B1B"/>
+              <a:srgbClr val="1E40AF"/>
             </a:solidFill>
           </a:ln>
           <a:effectLst/>
@@ -7766,8 +7852,8 @@
         </p:nvSpPr>
         <p:spPr>
           <a:xfrm>
-            <a:off x="914400" y="5074920"/>
-            <a:ext cx="10424160" cy="731520"/>
+            <a:off x="914400" y="5120640"/>
+            <a:ext cx="10424160" cy="693420"/>
           </a:xfrm>
           <a:prstGeom prst="rect">
             <a:avLst/>
@@ -7786,13 +7872,13 @@
               </a:spcAft>
             </a:pPr>
             <a:r>
-              <a:rPr sz="2400" b="1">
-                <a:solidFill>
-                  <a:srgbClr val="991B1B"/>
+              <a:rPr sz="2200" b="1">
+                <a:solidFill>
+                  <a:srgbClr val="1E40AF"/>
                 </a:solidFill>
                 <a:latin typeface="Calibri"/>
               </a:rPr>
-              <a:t>Tương phản làm nổi bật nỗi cô đơn.</a:t>
+              <a:t>💡 Cái gì nhỏ bé, cái gì rộng lớn?</a:t>
             </a:r>
           </a:p>
         </p:txBody>
@@ -7875,14 +7961,14 @@
         </p:nvSpPr>
         <p:spPr>
           <a:xfrm>
-            <a:off x="10253167" y="457200"/>
-            <a:ext cx="1389888" cy="457200"/>
+            <a:off x="9942271" y="457200"/>
+            <a:ext cx="1700784" cy="457200"/>
           </a:xfrm>
           <a:prstGeom prst="roundRect">
             <a:avLst/>
           </a:prstGeom>
           <a:solidFill>
-            <a:srgbClr val="1E40AF"/>
+            <a:srgbClr val="991B1B"/>
           </a:solidFill>
           <a:ln>
             <a:noFill/>
@@ -7915,7 +8001,7 @@
                 </a:solidFill>
                 <a:latin typeface="Arial"/>
               </a:rPr>
-              <a:t>ĐỀ BÀI</a:t>
+              <a:t>LỜI GIẢI</a:t>
             </a:r>
           </a:p>
         </p:txBody>
@@ -7929,7 +8015,7 @@
         <p:spPr>
           <a:xfrm>
             <a:off x="731520" y="274320"/>
-            <a:ext cx="9582912" cy="868680"/>
+            <a:ext cx="9272016" cy="868680"/>
           </a:xfrm>
           <a:prstGeom prst="rect">
             <a:avLst/>
@@ -7949,7 +8035,7 @@
                 </a:solidFill>
                 <a:latin typeface="Arial"/>
               </a:rPr>
-              <a:t>NGÔN NGỮ VÀ THI LIỆU</a:t>
+              <a:t>CẤU TỨ VÀ SỰ TƯƠNG PHẢN</a:t>
             </a:r>
           </a:p>
         </p:txBody>
@@ -8042,7 +8128,7 @@
         <p:spPr>
           <a:xfrm>
             <a:off x="731520" y="1463040"/>
-            <a:ext cx="10789920" cy="3566160"/>
+            <a:ext cx="10789920" cy="3474720"/>
           </a:xfrm>
           <a:prstGeom prst="rect">
             <a:avLst/>
@@ -8055,19 +8141,66 @@
           </a:bodyPr>
           <a:lstStyle/>
           <a:p>
-            <a:pPr algn="l">
+            <a:pPr algn="l" marL="365760" indent="-365760">
               <a:spcAft>
                 <a:spcPts val="800"/>
               </a:spcAft>
+              <a:buClr>
+                <a:srgbClr val="1E40AF"/>
+              </a:buClr>
+              <a:buFont typeface="Arial"/>
+              <a:buChar char="•"/>
             </a:pPr>
             <a:r>
-              <a:rPr sz="2600" b="1">
+              <a:rPr sz="2300">
                 <a:solidFill>
                   <a:srgbClr val="1E293B"/>
                 </a:solidFill>
                 <a:latin typeface="Calibri"/>
               </a:rPr>
-              <a:t>Bài thơ có những điểm khác lạ nào trong cách dùng ngôn ngữ? Nêu một số thi liệu truyền thống và ý nghĩa của chúng.</a:t>
+              <a:t>Cấu tứ: vô hạn của vũ trụ ↔ hữu hạn, nhỏ bé của con người.</a:t>
+            </a:r>
+          </a:p>
+          <a:p>
+            <a:pPr algn="l" marL="365760" indent="-365760">
+              <a:spcAft>
+                <a:spcPts val="800"/>
+              </a:spcAft>
+              <a:buClr>
+                <a:srgbClr val="1E40AF"/>
+              </a:buClr>
+              <a:buFont typeface="Arial"/>
+              <a:buChar char="•"/>
+            </a:pPr>
+            <a:r>
+              <a:rPr sz="2300">
+                <a:solidFill>
+                  <a:srgbClr val="1E293B"/>
+                </a:solidFill>
+                <a:latin typeface="Calibri"/>
+              </a:rPr>
+              <a:t>Khổ 2: “lơ thơ cồn nhỏ” ↔ “sông dài, trời rộng”.</a:t>
+            </a:r>
+          </a:p>
+          <a:p>
+            <a:pPr algn="l" marL="365760" indent="-365760">
+              <a:spcAft>
+                <a:spcPts val="800"/>
+              </a:spcAft>
+              <a:buClr>
+                <a:srgbClr val="1E40AF"/>
+              </a:buClr>
+              <a:buFont typeface="Arial"/>
+              <a:buChar char="•"/>
+            </a:pPr>
+            <a:r>
+              <a:rPr sz="2300">
+                <a:solidFill>
+                  <a:srgbClr val="1E293B"/>
+                </a:solidFill>
+                <a:latin typeface="Calibri"/>
+              </a:rPr>
+              <a:t>Khổ 3: bèo dạt – không đò, không cầu; khổ 4: mây núi bạc – cánh chim nhỏ.</a:t>
             </a:r>
           </a:p>
         </p:txBody>
@@ -8080,8 +8213,8 @@
         </p:nvSpPr>
         <p:spPr>
           <a:xfrm>
-            <a:off x="731520" y="5120640"/>
-            <a:ext cx="10789920" cy="693420"/>
+            <a:off x="731520" y="5074920"/>
+            <a:ext cx="10789920" cy="731520"/>
           </a:xfrm>
           <a:prstGeom prst="roundRect">
             <a:avLst>
@@ -8089,11 +8222,11 @@
             </a:avLst>
           </a:prstGeom>
           <a:solidFill>
-            <a:srgbClr val="EFF4FF"/>
+            <a:srgbClr val="FEF2F2"/>
           </a:solidFill>
           <a:ln w="19050">
             <a:solidFill>
-              <a:srgbClr val="1E40AF"/>
+              <a:srgbClr val="991B1B"/>
             </a:solidFill>
           </a:ln>
           <a:effectLst/>
@@ -8128,8 +8261,8 @@
         </p:nvSpPr>
         <p:spPr>
           <a:xfrm>
-            <a:off x="914400" y="5120640"/>
-            <a:ext cx="10424160" cy="693420"/>
+            <a:off x="914400" y="5074920"/>
+            <a:ext cx="10424160" cy="731520"/>
           </a:xfrm>
           <a:prstGeom prst="rect">
             <a:avLst/>
@@ -8148,13 +8281,13 @@
               </a:spcAft>
             </a:pPr>
             <a:r>
-              <a:rPr sz="2200" b="1">
-                <a:solidFill>
-                  <a:srgbClr val="1E40AF"/>
+              <a:rPr sz="2400" b="1">
+                <a:solidFill>
+                  <a:srgbClr val="991B1B"/>
                 </a:solidFill>
                 <a:latin typeface="Calibri"/>
               </a:rPr>
-              <a:t>💡 Chú ý “buồn điệp điệp”, “sâu chót vót”.</a:t>
+              <a:t>Tương phản làm nổi bật nỗi cô đơn.</a:t>
             </a:r>
           </a:p>
         </p:txBody>
@@ -8237,14 +8370,14 @@
         </p:nvSpPr>
         <p:spPr>
           <a:xfrm>
-            <a:off x="9942271" y="457200"/>
-            <a:ext cx="1700784" cy="457200"/>
+            <a:off x="10253167" y="457200"/>
+            <a:ext cx="1389888" cy="457200"/>
           </a:xfrm>
           <a:prstGeom prst="roundRect">
             <a:avLst/>
           </a:prstGeom>
           <a:solidFill>
-            <a:srgbClr val="991B1B"/>
+            <a:srgbClr val="1E40AF"/>
           </a:solidFill>
           <a:ln>
             <a:noFill/>
@@ -8277,7 +8410,7 @@
                 </a:solidFill>
                 <a:latin typeface="Arial"/>
               </a:rPr>
-              <a:t>LỜI GIẢI</a:t>
+              <a:t>ĐỀ BÀI</a:t>
             </a:r>
           </a:p>
         </p:txBody>
@@ -8291,7 +8424,7 @@
         <p:spPr>
           <a:xfrm>
             <a:off x="731520" y="274320"/>
-            <a:ext cx="9272016" cy="868680"/>
+            <a:ext cx="9582912" cy="868680"/>
           </a:xfrm>
           <a:prstGeom prst="rect">
             <a:avLst/>
@@ -8404,7 +8537,7 @@
         <p:spPr>
           <a:xfrm>
             <a:off x="731520" y="1463040"/>
-            <a:ext cx="10789920" cy="3474720"/>
+            <a:ext cx="10789920" cy="3566160"/>
           </a:xfrm>
           <a:prstGeom prst="rect">
             <a:avLst/>
@@ -8417,66 +8550,19 @@
           </a:bodyPr>
           <a:lstStyle/>
           <a:p>
-            <a:pPr algn="l" marL="365760" indent="-365760">
+            <a:pPr algn="l">
               <a:spcAft>
                 <a:spcPts val="800"/>
               </a:spcAft>
-              <a:buClr>
-                <a:srgbClr val="1E40AF"/>
-              </a:buClr>
-              <a:buFont typeface="Arial"/>
-              <a:buChar char="•"/>
             </a:pPr>
             <a:r>
-              <a:rPr sz="2300">
+              <a:rPr sz="2600" b="1">
                 <a:solidFill>
                   <a:srgbClr val="1E293B"/>
                 </a:solidFill>
                 <a:latin typeface="Calibri"/>
               </a:rPr>
-              <a:t>“buồn điệp điệp”, “sâu chót vót”, “củi / một cành khô”, dấu hai chấm “cánh nhỏ: bóng chiều sa”.</a:t>
-            </a:r>
-          </a:p>
-          <a:p>
-            <a:pPr algn="l" marL="365760" indent="-365760">
-              <a:spcAft>
-                <a:spcPts val="800"/>
-              </a:spcAft>
-              <a:buClr>
-                <a:srgbClr val="1E40AF"/>
-              </a:buClr>
-              <a:buFont typeface="Arial"/>
-              <a:buChar char="•"/>
-            </a:pPr>
-            <a:r>
-              <a:rPr sz="2300">
-                <a:solidFill>
-                  <a:srgbClr val="1E293B"/>
-                </a:solidFill>
-                <a:latin typeface="Calibri"/>
-              </a:rPr>
-              <a:t>Thi liệu: tràng giang, thuyền, cánh chim, bóng chiều, khói hoàng hôn.</a:t>
-            </a:r>
-          </a:p>
-          <a:p>
-            <a:pPr algn="l" marL="365760" indent="-365760">
-              <a:spcAft>
-                <a:spcPts val="800"/>
-              </a:spcAft>
-              <a:buClr>
-                <a:srgbClr val="1E40AF"/>
-              </a:buClr>
-              <a:buFont typeface="Arial"/>
-              <a:buChar char="•"/>
-            </a:pPr>
-            <a:r>
-              <a:rPr sz="2300">
-                <a:solidFill>
-                  <a:srgbClr val="1E293B"/>
-                </a:solidFill>
-                <a:latin typeface="Calibri"/>
-              </a:rPr>
-              <a:t>“Không khói hoàng hôn cũng nhớ nhà” – mượn tứ Thôi Hiệu nhưng mới.</a:t>
+              <a:t>Bài thơ có những điểm khác lạ nào trong cách dùng ngôn ngữ? Nêu một số thi liệu truyền thống và ý nghĩa của chúng.</a:t>
             </a:r>
           </a:p>
         </p:txBody>
@@ -8489,8 +8575,8 @@
         </p:nvSpPr>
         <p:spPr>
           <a:xfrm>
-            <a:off x="731520" y="5074920"/>
-            <a:ext cx="10789920" cy="731520"/>
+            <a:off x="731520" y="5120640"/>
+            <a:ext cx="10789920" cy="693420"/>
           </a:xfrm>
           <a:prstGeom prst="roundRect">
             <a:avLst>
@@ -8498,11 +8584,11 @@
             </a:avLst>
           </a:prstGeom>
           <a:solidFill>
-            <a:srgbClr val="FEF2F2"/>
+            <a:srgbClr val="EFF4FF"/>
           </a:solidFill>
           <a:ln w="19050">
             <a:solidFill>
-              <a:srgbClr val="991B1B"/>
+              <a:srgbClr val="1E40AF"/>
             </a:solidFill>
           </a:ln>
           <a:effectLst/>
@@ -8537,8 +8623,8 @@
         </p:nvSpPr>
         <p:spPr>
           <a:xfrm>
-            <a:off x="914400" y="5074920"/>
-            <a:ext cx="10424160" cy="731520"/>
+            <a:off x="914400" y="5120640"/>
+            <a:ext cx="10424160" cy="693420"/>
           </a:xfrm>
           <a:prstGeom prst="rect">
             <a:avLst/>
@@ -8557,13 +8643,13 @@
               </a:spcAft>
             </a:pPr>
             <a:r>
-              <a:rPr sz="2400" b="1">
-                <a:solidFill>
-                  <a:srgbClr val="991B1B"/>
+              <a:rPr sz="2200" b="1">
+                <a:solidFill>
+                  <a:srgbClr val="1E40AF"/>
                 </a:solidFill>
                 <a:latin typeface="Calibri"/>
               </a:rPr>
-              <a:t>Cổ điển mà hiện đại.</a:t>
+              <a:t>💡 Chú ý “buồn điệp điệp”, “sâu chót vót”.</a:t>
             </a:r>
           </a:p>
         </p:txBody>
@@ -8967,7 +9053,7 @@
     <p:bg>
       <p:bgPr>
         <a:solidFill>
-          <a:srgbClr val="F8F9FA"/>
+          <a:srgbClr val="FFFFFF"/>
         </a:solidFill>
         <a:effectLst/>
       </p:bgPr>
@@ -8987,10 +9073,54 @@
         </p:nvSpPr>
         <p:spPr>
           <a:xfrm>
-            <a:off x="548640" y="2926080"/>
-            <a:ext cx="164592" cy="1005840"/>
-          </a:xfrm>
-          <a:prstGeom prst="rect">
+            <a:off x="457200" y="384048"/>
+            <a:ext cx="109728" cy="658368"/>
+          </a:xfrm>
+          <a:prstGeom prst="rect">
+            <a:avLst/>
+          </a:prstGeom>
+          <a:solidFill>
+            <a:srgbClr val="1E40AF"/>
+          </a:solidFill>
+          <a:ln>
+            <a:noFill/>
+          </a:ln>
+          <a:effectLst/>
+        </p:spPr>
+        <p:style>
+          <a:lnRef idx="1">
+            <a:schemeClr val="accent1"/>
+          </a:lnRef>
+          <a:fillRef idx="3">
+            <a:schemeClr val="accent1"/>
+          </a:fillRef>
+          <a:effectRef idx="2">
+            <a:schemeClr val="accent1"/>
+          </a:effectRef>
+          <a:fontRef idx="minor">
+            <a:schemeClr val="lt1"/>
+          </a:fontRef>
+        </p:style>
+        <p:txBody>
+          <a:bodyPr rtlCol="0" anchor="ctr"/>
+          <a:lstStyle/>
+          <a:p>
+            <a:pPr algn="ctr"/>
+          </a:p>
+        </p:txBody>
+      </p:sp>
+      <p:sp>
+        <p:nvSpPr>
+          <p:cNvPr id="3" name="Rounded Rectangle 2"/>
+          <p:cNvSpPr/>
+          <p:nvPr/>
+        </p:nvSpPr>
+        <p:spPr>
+          <a:xfrm>
+            <a:off x="9942271" y="457200"/>
+            <a:ext cx="1700784" cy="457200"/>
+          </a:xfrm>
+          <a:prstGeom prst="roundRect">
             <a:avLst/>
           </a:prstGeom>
           <a:solidFill>
@@ -9016,6 +9146,93 @@
           </a:fontRef>
         </p:style>
         <p:txBody>
+          <a:bodyPr rtlCol="0" anchor="ctr" wrap="none" tIns="0" bIns="0"/>
+          <a:lstStyle/>
+          <a:p>
+            <a:pPr algn="ctr"/>
+            <a:r>
+              <a:rPr sz="1400" b="1">
+                <a:solidFill>
+                  <a:srgbClr val="FFFFFF"/>
+                </a:solidFill>
+                <a:latin typeface="Arial"/>
+              </a:rPr>
+              <a:t>LỜI GIẢI</a:t>
+            </a:r>
+          </a:p>
+        </p:txBody>
+      </p:sp>
+      <p:sp>
+        <p:nvSpPr>
+          <p:cNvPr id="4" name="TextBox 3"/>
+          <p:cNvSpPr txBox="1"/>
+          <p:nvPr/>
+        </p:nvSpPr>
+        <p:spPr>
+          <a:xfrm>
+            <a:off x="731520" y="274320"/>
+            <a:ext cx="9272016" cy="868680"/>
+          </a:xfrm>
+          <a:prstGeom prst="rect">
+            <a:avLst/>
+          </a:prstGeom>
+          <a:noFill/>
+        </p:spPr>
+        <p:txBody>
+          <a:bodyPr wrap="square" anchor="ctr">
+            <a:spAutoFit/>
+          </a:bodyPr>
+          <a:lstStyle/>
+          <a:p>
+            <a:r>
+              <a:rPr sz="3600" b="1">
+                <a:solidFill>
+                  <a:srgbClr val="1E40AF"/>
+                </a:solidFill>
+                <a:latin typeface="Arial"/>
+              </a:rPr>
+              <a:t>NGÔN NGỮ VÀ THI LIỆU</a:t>
+            </a:r>
+          </a:p>
+        </p:txBody>
+      </p:sp>
+      <p:sp>
+        <p:nvSpPr>
+          <p:cNvPr id="5" name="Rectangle 4"/>
+          <p:cNvSpPr/>
+          <p:nvPr/>
+        </p:nvSpPr>
+        <p:spPr>
+          <a:xfrm>
+            <a:off x="457200" y="1207008"/>
+            <a:ext cx="11274552" cy="22000"/>
+          </a:xfrm>
+          <a:prstGeom prst="rect">
+            <a:avLst/>
+          </a:prstGeom>
+          <a:solidFill>
+            <a:srgbClr val="E2E8F0"/>
+          </a:solidFill>
+          <a:ln>
+            <a:noFill/>
+          </a:ln>
+          <a:effectLst/>
+        </p:spPr>
+        <p:style>
+          <a:lnRef idx="1">
+            <a:schemeClr val="accent1"/>
+          </a:lnRef>
+          <a:fillRef idx="3">
+            <a:schemeClr val="accent1"/>
+          </a:fillRef>
+          <a:effectRef idx="2">
+            <a:schemeClr val="accent1"/>
+          </a:effectRef>
+          <a:fontRef idx="minor">
+            <a:schemeClr val="lt1"/>
+          </a:fontRef>
+        </p:style>
+        <p:txBody>
           <a:bodyPr rtlCol="0" anchor="ctr"/>
           <a:lstStyle/>
           <a:p>
@@ -9025,14 +9242,183 @@
       </p:sp>
       <p:sp>
         <p:nvSpPr>
-          <p:cNvPr id="3" name="TextBox 2"/>
+          <p:cNvPr id="6" name="TextBox 5"/>
           <p:cNvSpPr txBox="1"/>
           <p:nvPr/>
         </p:nvSpPr>
         <p:spPr>
           <a:xfrm>
-            <a:off x="914400" y="2743200"/>
-            <a:ext cx="10515600" cy="1371600"/>
+            <a:off x="457200" y="6355080"/>
+            <a:ext cx="11274552" cy="365760"/>
+          </a:xfrm>
+          <a:prstGeom prst="rect">
+            <a:avLst/>
+          </a:prstGeom>
+          <a:noFill/>
+        </p:spPr>
+        <p:txBody>
+          <a:bodyPr wrap="none">
+            <a:spAutoFit/>
+          </a:bodyPr>
+          <a:lstStyle/>
+          <a:p>
+            <a:pPr algn="r"/>
+            <a:r>
+              <a:rPr sz="1200">
+                <a:solidFill>
+                  <a:srgbClr val="64748B"/>
+                </a:solidFill>
+                <a:latin typeface="Calibri"/>
+              </a:rPr>
+              <a:t>Ngữ văn 11 · Bài 2: Cấu Tứ Và Hình Ảnh Trong Thơ Trữ Tình          20</a:t>
+            </a:r>
+          </a:p>
+        </p:txBody>
+      </p:sp>
+      <p:sp>
+        <p:nvSpPr>
+          <p:cNvPr id="7" name="TextBox 6"/>
+          <p:cNvSpPr txBox="1"/>
+          <p:nvPr/>
+        </p:nvSpPr>
+        <p:spPr>
+          <a:xfrm>
+            <a:off x="731520" y="1463040"/>
+            <a:ext cx="10789920" cy="3474720"/>
+          </a:xfrm>
+          <a:prstGeom prst="rect">
+            <a:avLst/>
+          </a:prstGeom>
+          <a:noFill/>
+        </p:spPr>
+        <p:txBody>
+          <a:bodyPr wrap="square" anchor="t" lIns="45720" rIns="45720">
+            <a:spAutoFit/>
+          </a:bodyPr>
+          <a:lstStyle/>
+          <a:p>
+            <a:pPr algn="l" marL="365760" indent="-365760">
+              <a:spcAft>
+                <a:spcPts val="800"/>
+              </a:spcAft>
+              <a:buClr>
+                <a:srgbClr val="1E40AF"/>
+              </a:buClr>
+              <a:buFont typeface="Arial"/>
+              <a:buChar char="•"/>
+            </a:pPr>
+            <a:r>
+              <a:rPr sz="2300">
+                <a:solidFill>
+                  <a:srgbClr val="1E293B"/>
+                </a:solidFill>
+                <a:latin typeface="Calibri"/>
+              </a:rPr>
+              <a:t>“buồn điệp điệp”, “sâu chót vót”, “củi / một cành khô”, dấu hai chấm “cánh nhỏ: bóng chiều sa”.</a:t>
+            </a:r>
+          </a:p>
+          <a:p>
+            <a:pPr algn="l" marL="365760" indent="-365760">
+              <a:spcAft>
+                <a:spcPts val="800"/>
+              </a:spcAft>
+              <a:buClr>
+                <a:srgbClr val="1E40AF"/>
+              </a:buClr>
+              <a:buFont typeface="Arial"/>
+              <a:buChar char="•"/>
+            </a:pPr>
+            <a:r>
+              <a:rPr sz="2300">
+                <a:solidFill>
+                  <a:srgbClr val="1E293B"/>
+                </a:solidFill>
+                <a:latin typeface="Calibri"/>
+              </a:rPr>
+              <a:t>Thi liệu: tràng giang, thuyền, cánh chim, bóng chiều, khói hoàng hôn.</a:t>
+            </a:r>
+          </a:p>
+          <a:p>
+            <a:pPr algn="l" marL="365760" indent="-365760">
+              <a:spcAft>
+                <a:spcPts val="800"/>
+              </a:spcAft>
+              <a:buClr>
+                <a:srgbClr val="1E40AF"/>
+              </a:buClr>
+              <a:buFont typeface="Arial"/>
+              <a:buChar char="•"/>
+            </a:pPr>
+            <a:r>
+              <a:rPr sz="2300">
+                <a:solidFill>
+                  <a:srgbClr val="1E293B"/>
+                </a:solidFill>
+                <a:latin typeface="Calibri"/>
+              </a:rPr>
+              <a:t>“Không khói hoàng hôn cũng nhớ nhà” – mượn tứ Thôi Hiệu nhưng mới.</a:t>
+            </a:r>
+          </a:p>
+        </p:txBody>
+      </p:sp>
+      <p:sp>
+        <p:nvSpPr>
+          <p:cNvPr id="8" name="Rounded Rectangle 7"/>
+          <p:cNvSpPr/>
+          <p:nvPr/>
+        </p:nvSpPr>
+        <p:spPr>
+          <a:xfrm>
+            <a:off x="731520" y="5074920"/>
+            <a:ext cx="10789920" cy="731520"/>
+          </a:xfrm>
+          <a:prstGeom prst="roundRect">
+            <a:avLst>
+              <a:gd name="adj" fmla="val 8000"/>
+            </a:avLst>
+          </a:prstGeom>
+          <a:solidFill>
+            <a:srgbClr val="FEF2F2"/>
+          </a:solidFill>
+          <a:ln w="19050">
+            <a:solidFill>
+              <a:srgbClr val="991B1B"/>
+            </a:solidFill>
+          </a:ln>
+          <a:effectLst/>
+        </p:spPr>
+        <p:style>
+          <a:lnRef idx="1">
+            <a:schemeClr val="accent1"/>
+          </a:lnRef>
+          <a:fillRef idx="3">
+            <a:schemeClr val="accent1"/>
+          </a:fillRef>
+          <a:effectRef idx="2">
+            <a:schemeClr val="accent1"/>
+          </a:effectRef>
+          <a:fontRef idx="minor">
+            <a:schemeClr val="lt1"/>
+          </a:fontRef>
+        </p:style>
+        <p:txBody>
+          <a:bodyPr rtlCol="0" anchor="ctr"/>
+          <a:lstStyle/>
+          <a:p>
+            <a:pPr algn="ctr"/>
+          </a:p>
+        </p:txBody>
+      </p:sp>
+      <p:sp>
+        <p:nvSpPr>
+          <p:cNvPr id="9" name="TextBox 8"/>
+          <p:cNvSpPr txBox="1"/>
+          <p:nvPr/>
+        </p:nvSpPr>
+        <p:spPr>
+          <a:xfrm>
+            <a:off x="914400" y="5074920"/>
+            <a:ext cx="10424160" cy="731520"/>
           </a:xfrm>
           <a:prstGeom prst="rect">
             <a:avLst/>
@@ -9047,17 +9433,17 @@
           <a:p>
             <a:pPr algn="l">
               <a:spcAft>
-                <a:spcPts val="800"/>
+                <a:spcPts val="400"/>
               </a:spcAft>
             </a:pPr>
             <a:r>
-              <a:rPr sz="3600" b="1">
-                <a:solidFill>
-                  <a:srgbClr val="1E40AF"/>
+              <a:rPr sz="2400" b="1">
+                <a:solidFill>
+                  <a:srgbClr val="991B1B"/>
                 </a:solidFill>
                 <a:latin typeface="Calibri"/>
               </a:rPr>
-              <a:t>TIẾT 18: CON ĐƯỜNG MÙA ĐÔNG (Pu-skin)</a:t>
+              <a:t>Cổ điển mà hiện đại.</a:t>
             </a:r>
           </a:p>
         </p:txBody>
@@ -9076,7 +9462,7 @@
     <p:bg>
       <p:bgPr>
         <a:solidFill>
-          <a:srgbClr val="FFFFFF"/>
+          <a:srgbClr val="F8F9FA"/>
         </a:solidFill>
         <a:effectLst/>
       </p:bgPr>
@@ -9096,14 +9482,14 @@
         </p:nvSpPr>
         <p:spPr>
           <a:xfrm>
-            <a:off x="457200" y="384048"/>
-            <a:ext cx="109728" cy="658368"/>
+            <a:off x="548640" y="2926080"/>
+            <a:ext cx="164592" cy="1005840"/>
           </a:xfrm>
           <a:prstGeom prst="rect">
             <a:avLst/>
           </a:prstGeom>
           <a:solidFill>
-            <a:srgbClr val="1E40AF"/>
+            <a:srgbClr val="991B1B"/>
           </a:solidFill>
           <a:ln>
             <a:noFill/>
@@ -9134,67 +9520,14 @@
       </p:sp>
       <p:sp>
         <p:nvSpPr>
-          <p:cNvPr id="3" name="Rounded Rectangle 2"/>
-          <p:cNvSpPr/>
-          <p:nvPr/>
-        </p:nvSpPr>
-        <p:spPr>
-          <a:xfrm>
-            <a:off x="10253167" y="457200"/>
-            <a:ext cx="1389888" cy="457200"/>
-          </a:xfrm>
-          <a:prstGeom prst="roundRect">
-            <a:avLst/>
-          </a:prstGeom>
-          <a:solidFill>
-            <a:srgbClr val="1E40AF"/>
-          </a:solidFill>
-          <a:ln>
-            <a:noFill/>
-          </a:ln>
-          <a:effectLst/>
-        </p:spPr>
-        <p:style>
-          <a:lnRef idx="1">
-            <a:schemeClr val="accent1"/>
-          </a:lnRef>
-          <a:fillRef idx="3">
-            <a:schemeClr val="accent1"/>
-          </a:fillRef>
-          <a:effectRef idx="2">
-            <a:schemeClr val="accent1"/>
-          </a:effectRef>
-          <a:fontRef idx="minor">
-            <a:schemeClr val="lt1"/>
-          </a:fontRef>
-        </p:style>
-        <p:txBody>
-          <a:bodyPr rtlCol="0" anchor="ctr" wrap="none" tIns="0" bIns="0"/>
-          <a:lstStyle/>
-          <a:p>
-            <a:pPr algn="ctr"/>
-            <a:r>
-              <a:rPr sz="1400" b="1">
-                <a:solidFill>
-                  <a:srgbClr val="FFFFFF"/>
-                </a:solidFill>
-                <a:latin typeface="Arial"/>
-              </a:rPr>
-              <a:t>ĐỀ BÀI</a:t>
-            </a:r>
-          </a:p>
-        </p:txBody>
-      </p:sp>
-      <p:sp>
-        <p:nvSpPr>
-          <p:cNvPr id="4" name="TextBox 3"/>
+          <p:cNvPr id="3" name="TextBox 2"/>
           <p:cNvSpPr txBox="1"/>
           <p:nvPr/>
         </p:nvSpPr>
         <p:spPr>
           <a:xfrm>
-            <a:off x="731520" y="274320"/>
-            <a:ext cx="9582912" cy="868680"/>
+            <a:off x="914400" y="2743200"/>
+            <a:ext cx="10515600" cy="1371600"/>
           </a:xfrm>
           <a:prstGeom prst="rect">
             <a:avLst/>
@@ -9202,120 +9535,7 @@
           <a:noFill/>
         </p:spPr>
         <p:txBody>
-          <a:bodyPr wrap="square" anchor="ctr">
-            <a:spAutoFit/>
-          </a:bodyPr>
-          <a:lstStyle/>
-          <a:p>
-            <a:r>
-              <a:rPr sz="3600" b="1">
-                <a:solidFill>
-                  <a:srgbClr val="1E40AF"/>
-                </a:solidFill>
-                <a:latin typeface="Arial"/>
-              </a:rPr>
-              <a:t>NỖI BUỒN VÀ Ý THỨC VƯỢT QUA</a:t>
-            </a:r>
-          </a:p>
-        </p:txBody>
-      </p:sp>
-      <p:sp>
-        <p:nvSpPr>
-          <p:cNvPr id="5" name="Rectangle 4"/>
-          <p:cNvSpPr/>
-          <p:nvPr/>
-        </p:nvSpPr>
-        <p:spPr>
-          <a:xfrm>
-            <a:off x="457200" y="1207008"/>
-            <a:ext cx="11274552" cy="22000"/>
-          </a:xfrm>
-          <a:prstGeom prst="rect">
-            <a:avLst/>
-          </a:prstGeom>
-          <a:solidFill>
-            <a:srgbClr val="E2E8F0"/>
-          </a:solidFill>
-          <a:ln>
-            <a:noFill/>
-          </a:ln>
-          <a:effectLst/>
-        </p:spPr>
-        <p:style>
-          <a:lnRef idx="1">
-            <a:schemeClr val="accent1"/>
-          </a:lnRef>
-          <a:fillRef idx="3">
-            <a:schemeClr val="accent1"/>
-          </a:fillRef>
-          <a:effectRef idx="2">
-            <a:schemeClr val="accent1"/>
-          </a:effectRef>
-          <a:fontRef idx="minor">
-            <a:schemeClr val="lt1"/>
-          </a:fontRef>
-        </p:style>
-        <p:txBody>
-          <a:bodyPr rtlCol="0" anchor="ctr"/>
-          <a:lstStyle/>
-          <a:p>
-            <a:pPr algn="ctr"/>
-          </a:p>
-        </p:txBody>
-      </p:sp>
-      <p:sp>
-        <p:nvSpPr>
-          <p:cNvPr id="6" name="TextBox 5"/>
-          <p:cNvSpPr txBox="1"/>
-          <p:nvPr/>
-        </p:nvSpPr>
-        <p:spPr>
-          <a:xfrm>
-            <a:off x="457200" y="6355080"/>
-            <a:ext cx="11274552" cy="365760"/>
-          </a:xfrm>
-          <a:prstGeom prst="rect">
-            <a:avLst/>
-          </a:prstGeom>
-          <a:noFill/>
-        </p:spPr>
-        <p:txBody>
-          <a:bodyPr wrap="none">
-            <a:spAutoFit/>
-          </a:bodyPr>
-          <a:lstStyle/>
-          <a:p>
-            <a:pPr algn="r"/>
-            <a:r>
-              <a:rPr sz="1200">
-                <a:solidFill>
-                  <a:srgbClr val="64748B"/>
-                </a:solidFill>
-                <a:latin typeface="Calibri"/>
-              </a:rPr>
-              <a:t>Ngữ văn 11 · Bài 2: Cấu Tứ Và Hình Ảnh Trong Thơ Trữ Tình          21</a:t>
-            </a:r>
-          </a:p>
-        </p:txBody>
-      </p:sp>
-      <p:sp>
-        <p:nvSpPr>
-          <p:cNvPr id="7" name="TextBox 6"/>
-          <p:cNvSpPr txBox="1"/>
-          <p:nvPr/>
-        </p:nvSpPr>
-        <p:spPr>
-          <a:xfrm>
-            <a:off x="731520" y="1463040"/>
-            <a:ext cx="10789920" cy="3566160"/>
-          </a:xfrm>
-          <a:prstGeom prst="rect">
-            <a:avLst/>
-          </a:prstGeom>
-          <a:noFill/>
-        </p:spPr>
-        <p:txBody>
-          <a:bodyPr wrap="square" anchor="t" lIns="45720" rIns="45720">
+          <a:bodyPr wrap="square" anchor="ctr" lIns="45720" rIns="45720">
             <a:spAutoFit/>
           </a:bodyPr>
           <a:lstStyle/>
@@ -9326,100 +9546,13 @@
               </a:spcAft>
             </a:pPr>
             <a:r>
-              <a:rPr sz="2600" b="1">
-                <a:solidFill>
-                  <a:srgbClr val="1E293B"/>
+              <a:rPr sz="3600" b="1">
+                <a:solidFill>
+                  <a:srgbClr val="1E40AF"/>
                 </a:solidFill>
                 <a:latin typeface="Calibri"/>
               </a:rPr>
-              <a:t>Những hình ảnh, âm thanh trong bài thơ diễn tả mâu thuẫn giữa nỗi buồn với ý thức vượt qua trở ngại của nhân vật trữ tình như thế nào?</a:t>
-            </a:r>
-          </a:p>
-        </p:txBody>
-      </p:sp>
-      <p:sp>
-        <p:nvSpPr>
-          <p:cNvPr id="8" name="Rounded Rectangle 7"/>
-          <p:cNvSpPr/>
-          <p:nvPr/>
-        </p:nvSpPr>
-        <p:spPr>
-          <a:xfrm>
-            <a:off x="731520" y="5120640"/>
-            <a:ext cx="10789920" cy="693420"/>
-          </a:xfrm>
-          <a:prstGeom prst="roundRect">
-            <a:avLst>
-              <a:gd name="adj" fmla="val 8000"/>
-            </a:avLst>
-          </a:prstGeom>
-          <a:solidFill>
-            <a:srgbClr val="EFF4FF"/>
-          </a:solidFill>
-          <a:ln w="19050">
-            <a:solidFill>
-              <a:srgbClr val="1E40AF"/>
-            </a:solidFill>
-          </a:ln>
-          <a:effectLst/>
-        </p:spPr>
-        <p:style>
-          <a:lnRef idx="1">
-            <a:schemeClr val="accent1"/>
-          </a:lnRef>
-          <a:fillRef idx="3">
-            <a:schemeClr val="accent1"/>
-          </a:fillRef>
-          <a:effectRef idx="2">
-            <a:schemeClr val="accent1"/>
-          </a:effectRef>
-          <a:fontRef idx="minor">
-            <a:schemeClr val="lt1"/>
-          </a:fontRef>
-        </p:style>
-        <p:txBody>
-          <a:bodyPr rtlCol="0" anchor="ctr"/>
-          <a:lstStyle/>
-          <a:p>
-            <a:pPr algn="ctr"/>
-          </a:p>
-        </p:txBody>
-      </p:sp>
-      <p:sp>
-        <p:nvSpPr>
-          <p:cNvPr id="9" name="TextBox 8"/>
-          <p:cNvSpPr txBox="1"/>
-          <p:nvPr/>
-        </p:nvSpPr>
-        <p:spPr>
-          <a:xfrm>
-            <a:off x="914400" y="5120640"/>
-            <a:ext cx="10424160" cy="693420"/>
-          </a:xfrm>
-          <a:prstGeom prst="rect">
-            <a:avLst/>
-          </a:prstGeom>
-          <a:noFill/>
-        </p:spPr>
-        <p:txBody>
-          <a:bodyPr wrap="square" anchor="ctr" lIns="45720" rIns="45720">
-            <a:spAutoFit/>
-          </a:bodyPr>
-          <a:lstStyle/>
-          <a:p>
-            <a:pPr algn="l">
-              <a:spcAft>
-                <a:spcPts val="400"/>
-              </a:spcAft>
-            </a:pPr>
-            <a:r>
-              <a:rPr sz="2200" b="1">
-                <a:solidFill>
-                  <a:srgbClr val="1E40AF"/>
-                </a:solidFill>
-                <a:latin typeface="Calibri"/>
-              </a:rPr>
-              <a:t>💡 Trăng, cột sọc chỉ đường, tiếng lục lạc, kim đồng hồ…</a:t>
+              <a:t>TIẾT 18: CON ĐƯỜNG MÙA ĐÔNG (Pu-skin)</a:t>
             </a:r>
           </a:p>
         </p:txBody>
@@ -9502,8 +9635,8 @@
         </p:nvSpPr>
         <p:spPr>
           <a:xfrm>
-            <a:off x="9942271" y="457200"/>
-            <a:ext cx="1700784" cy="457200"/>
+            <a:off x="10408615" y="457200"/>
+            <a:ext cx="1234440" cy="457200"/>
           </a:xfrm>
           <a:prstGeom prst="roundRect">
             <a:avLst/>
@@ -9542,7 +9675,7 @@
                 </a:solidFill>
                 <a:latin typeface="Arial"/>
               </a:rPr>
-              <a:t>LỜI GIẢI</a:t>
+              <a:t>VIDEO</a:t>
             </a:r>
           </a:p>
         </p:txBody>
@@ -9556,7 +9689,7 @@
         <p:spPr>
           <a:xfrm>
             <a:off x="731520" y="274320"/>
-            <a:ext cx="9272016" cy="868680"/>
+            <a:ext cx="9738360" cy="868680"/>
           </a:xfrm>
           <a:prstGeom prst="rect">
             <a:avLst/>
@@ -9576,7 +9709,7 @@
                 </a:solidFill>
                 <a:latin typeface="Arial"/>
               </a:rPr>
-              <a:t>NỖI BUỒN VÀ Ý THỨC VƯỢT QUA</a:t>
+              <a:t>VIDEO THAM KHẢO</a:t>
             </a:r>
           </a:p>
         </p:txBody>
@@ -9660,16 +9793,40 @@
           </a:p>
         </p:txBody>
       </p:sp>
-      <p:sp>
-        <p:nvSpPr>
-          <p:cNvPr id="7" name="TextBox 6"/>
+      <p:pic>
+        <p:nvPicPr>
+          <p:cNvPr id="7" name="Picture 6" descr="QR_video_n7mqfl4VM3c.png"/>
+          <p:cNvPicPr>
+            <a:picLocks noChangeAspect="1"/>
+          </p:cNvPicPr>
+          <p:nvPr/>
+        </p:nvPicPr>
+        <p:blipFill>
+          <a:blip r:embed="rId2"/>
+          <a:stretch>
+            <a:fillRect/>
+          </a:stretch>
+        </p:blipFill>
+        <p:spPr>
+          <a:xfrm>
+            <a:off x="8412480" y="1554480"/>
+            <a:ext cx="3108960" cy="3108960"/>
+          </a:xfrm>
+          <a:prstGeom prst="rect">
+            <a:avLst/>
+          </a:prstGeom>
+        </p:spPr>
+      </p:pic>
+      <p:sp>
+        <p:nvSpPr>
+          <p:cNvPr id="8" name="TextBox 7"/>
           <p:cNvSpPr txBox="1"/>
           <p:nvPr/>
         </p:nvSpPr>
         <p:spPr>
           <a:xfrm>
-            <a:off x="731520" y="1463040"/>
-            <a:ext cx="10789920" cy="3474720"/>
+            <a:off x="731520" y="1554480"/>
+            <a:ext cx="7498079" cy="4206240"/>
           </a:xfrm>
           <a:prstGeom prst="rect">
             <a:avLst/>
@@ -9681,6 +9838,38 @@
             <a:spAutoFit/>
           </a:bodyPr>
           <a:lstStyle/>
+          <a:p>
+            <a:pPr algn="l">
+              <a:spcAft>
+                <a:spcPts val="800"/>
+              </a:spcAft>
+            </a:pPr>
+            <a:r>
+              <a:rPr sz="2600" b="1">
+                <a:solidFill>
+                  <a:srgbClr val="1E293B"/>
+                </a:solidFill>
+                <a:latin typeface="Calibri"/>
+              </a:rPr>
+              <a:t>🎬 Con đường mùa đông – Pu-skin (đọc thơ)</a:t>
+            </a:r>
+          </a:p>
+          <a:p>
+            <a:pPr algn="l">
+              <a:spcAft>
+                <a:spcPts val="800"/>
+              </a:spcAft>
+            </a:pPr>
+            <a:r>
+              <a:rPr sz="2000">
+                <a:solidFill>
+                  <a:srgbClr val="64748B"/>
+                </a:solidFill>
+                <a:latin typeface="Calibri"/>
+              </a:rPr>
+              <a:t>Kênh: MC Trần Thiện Tùng</a:t>
+            </a:r>
+          </a:p>
           <a:p>
             <a:pPr algn="l" marL="365760" indent="-365760">
               <a:spcAft>
@@ -9693,142 +9882,30 @@
               <a:buChar char="•"/>
             </a:pPr>
             <a:r>
-              <a:rPr sz="2300">
+              <a:rPr sz="2000">
                 <a:solidFill>
                   <a:srgbClr val="1E293B"/>
                 </a:solidFill>
                 <a:latin typeface="Calibri"/>
               </a:rPr>
-              <a:t>Trăng buồn, đường vắng, tiếng lục lạc đơn điệu – nỗi buồn.</a:t>
-            </a:r>
-          </a:p>
-          <a:p>
-            <a:pPr algn="l" marL="365760" indent="-365760">
+              <a:t>Đọc diễn cảm Con đường mùa đông</a:t>
+            </a:r>
+          </a:p>
+          <a:p>
+            <a:pPr algn="l">
               <a:spcAft>
                 <a:spcPts val="800"/>
               </a:spcAft>
-              <a:buClr>
-                <a:srgbClr val="1E40AF"/>
-              </a:buClr>
-              <a:buFont typeface="Arial"/>
-              <a:buChar char="•"/>
             </a:pPr>
             <a:r>
-              <a:rPr sz="2300">
-                <a:solidFill>
-                  <a:srgbClr val="1E293B"/>
+              <a:rPr sz="1600">
+                <a:solidFill>
+                  <a:srgbClr val="64748B"/>
                 </a:solidFill>
                 <a:latin typeface="Calibri"/>
-              </a:rPr>
-              <a:t>Xe tam mã lao nhanh, cột sọc chỉ đường – hành trình tiếp diễn.</a:t>
-            </a:r>
-          </a:p>
-          <a:p>
-            <a:pPr algn="l" marL="365760" indent="-365760">
-              <a:spcAft>
-                <a:spcPts val="800"/>
-              </a:spcAft>
-              <a:buClr>
-                <a:srgbClr val="1E40AF"/>
-              </a:buClr>
-              <a:buFont typeface="Arial"/>
-              <a:buChar char="•"/>
-            </a:pPr>
-            <a:r>
-              <a:rPr sz="2300">
-                <a:solidFill>
-                  <a:srgbClr val="1E293B"/>
-                </a:solidFill>
-                <a:latin typeface="Calibri"/>
-              </a:rPr>
-              <a:t>Tâm tưởng: Nhi-na, lò lửa đỏ – hơi ấm phía trước.</a:t>
-            </a:r>
-          </a:p>
-        </p:txBody>
-      </p:sp>
-      <p:sp>
-        <p:nvSpPr>
-          <p:cNvPr id="8" name="Rounded Rectangle 7"/>
-          <p:cNvSpPr/>
-          <p:nvPr/>
-        </p:nvSpPr>
-        <p:spPr>
-          <a:xfrm>
-            <a:off x="731520" y="5074920"/>
-            <a:ext cx="10789920" cy="731520"/>
-          </a:xfrm>
-          <a:prstGeom prst="roundRect">
-            <a:avLst>
-              <a:gd name="adj" fmla="val 8000"/>
-            </a:avLst>
-          </a:prstGeom>
-          <a:solidFill>
-            <a:srgbClr val="FEF2F2"/>
-          </a:solidFill>
-          <a:ln w="19050">
-            <a:solidFill>
-              <a:srgbClr val="991B1B"/>
-            </a:solidFill>
-          </a:ln>
-          <a:effectLst/>
-        </p:spPr>
-        <p:style>
-          <a:lnRef idx="1">
-            <a:schemeClr val="accent1"/>
-          </a:lnRef>
-          <a:fillRef idx="3">
-            <a:schemeClr val="accent1"/>
-          </a:fillRef>
-          <a:effectRef idx="2">
-            <a:schemeClr val="accent1"/>
-          </a:effectRef>
-          <a:fontRef idx="minor">
-            <a:schemeClr val="lt1"/>
-          </a:fontRef>
-        </p:style>
-        <p:txBody>
-          <a:bodyPr rtlCol="0" anchor="ctr"/>
-          <a:lstStyle/>
-          <a:p>
-            <a:pPr algn="ctr"/>
-          </a:p>
-        </p:txBody>
-      </p:sp>
-      <p:sp>
-        <p:nvSpPr>
-          <p:cNvPr id="9" name="TextBox 8"/>
-          <p:cNvSpPr txBox="1"/>
-          <p:nvPr/>
-        </p:nvSpPr>
-        <p:spPr>
-          <a:xfrm>
-            <a:off x="914400" y="5074920"/>
-            <a:ext cx="10424160" cy="731520"/>
-          </a:xfrm>
-          <a:prstGeom prst="rect">
-            <a:avLst/>
-          </a:prstGeom>
-          <a:noFill/>
-        </p:spPr>
-        <p:txBody>
-          <a:bodyPr wrap="square" anchor="ctr" lIns="45720" rIns="45720">
-            <a:spAutoFit/>
-          </a:bodyPr>
-          <a:lstStyle/>
-          <a:p>
-            <a:pPr algn="l">
-              <a:spcAft>
-                <a:spcPts val="400"/>
-              </a:spcAft>
-            </a:pPr>
-            <a:r>
-              <a:rPr sz="2400" b="1">
-                <a:solidFill>
-                  <a:srgbClr val="991B1B"/>
-                </a:solidFill>
-                <a:latin typeface="Calibri"/>
-              </a:rPr>
-              <a:t>Không chìm trong u buồn, luôn hướng tới niềm vui.</a:t>
+                <a:hlinkClick r:id="rId3"/>
+              </a:rPr>
+              <a:t>https://www.youtube.com/watch?v=n7mqfl4VM3c</a:t>
             </a:r>
           </a:p>
         </p:txBody>
@@ -9847,7 +9924,7 @@
     <p:bg>
       <p:bgPr>
         <a:solidFill>
-          <a:srgbClr val="F8F9FA"/>
+          <a:srgbClr val="FFFFFF"/>
         </a:solidFill>
         <a:effectLst/>
       </p:bgPr>
@@ -9867,14 +9944,14 @@
         </p:nvSpPr>
         <p:spPr>
           <a:xfrm>
-            <a:off x="548640" y="2926080"/>
-            <a:ext cx="164592" cy="1005840"/>
+            <a:off x="457200" y="384048"/>
+            <a:ext cx="109728" cy="658368"/>
           </a:xfrm>
           <a:prstGeom prst="rect">
             <a:avLst/>
           </a:prstGeom>
           <a:solidFill>
-            <a:srgbClr val="991B1B"/>
+            <a:srgbClr val="1E40AF"/>
           </a:solidFill>
           <a:ln>
             <a:noFill/>
@@ -9905,14 +9982,67 @@
       </p:sp>
       <p:sp>
         <p:nvSpPr>
-          <p:cNvPr id="3" name="TextBox 2"/>
+          <p:cNvPr id="3" name="Rounded Rectangle 2"/>
+          <p:cNvSpPr/>
+          <p:nvPr/>
+        </p:nvSpPr>
+        <p:spPr>
+          <a:xfrm>
+            <a:off x="10253167" y="457200"/>
+            <a:ext cx="1389888" cy="457200"/>
+          </a:xfrm>
+          <a:prstGeom prst="roundRect">
+            <a:avLst/>
+          </a:prstGeom>
+          <a:solidFill>
+            <a:srgbClr val="1E40AF"/>
+          </a:solidFill>
+          <a:ln>
+            <a:noFill/>
+          </a:ln>
+          <a:effectLst/>
+        </p:spPr>
+        <p:style>
+          <a:lnRef idx="1">
+            <a:schemeClr val="accent1"/>
+          </a:lnRef>
+          <a:fillRef idx="3">
+            <a:schemeClr val="accent1"/>
+          </a:fillRef>
+          <a:effectRef idx="2">
+            <a:schemeClr val="accent1"/>
+          </a:effectRef>
+          <a:fontRef idx="minor">
+            <a:schemeClr val="lt1"/>
+          </a:fontRef>
+        </p:style>
+        <p:txBody>
+          <a:bodyPr rtlCol="0" anchor="ctr" wrap="none" tIns="0" bIns="0"/>
+          <a:lstStyle/>
+          <a:p>
+            <a:pPr algn="ctr"/>
+            <a:r>
+              <a:rPr sz="1400" b="1">
+                <a:solidFill>
+                  <a:srgbClr val="FFFFFF"/>
+                </a:solidFill>
+                <a:latin typeface="Arial"/>
+              </a:rPr>
+              <a:t>ĐỀ BÀI</a:t>
+            </a:r>
+          </a:p>
+        </p:txBody>
+      </p:sp>
+      <p:sp>
+        <p:nvSpPr>
+          <p:cNvPr id="4" name="TextBox 3"/>
           <p:cNvSpPr txBox="1"/>
           <p:nvPr/>
         </p:nvSpPr>
         <p:spPr>
           <a:xfrm>
-            <a:off x="914400" y="2743200"/>
-            <a:ext cx="10515600" cy="1371600"/>
+            <a:off x="731520" y="274320"/>
+            <a:ext cx="9582912" cy="868680"/>
           </a:xfrm>
           <a:prstGeom prst="rect">
             <a:avLst/>
@@ -9920,7 +10050,120 @@
           <a:noFill/>
         </p:spPr>
         <p:txBody>
-          <a:bodyPr wrap="square" anchor="ctr" lIns="45720" rIns="45720">
+          <a:bodyPr wrap="square" anchor="ctr">
+            <a:spAutoFit/>
+          </a:bodyPr>
+          <a:lstStyle/>
+          <a:p>
+            <a:r>
+              <a:rPr sz="3600" b="1">
+                <a:solidFill>
+                  <a:srgbClr val="1E40AF"/>
+                </a:solidFill>
+                <a:latin typeface="Arial"/>
+              </a:rPr>
+              <a:t>NỖI BUỒN VÀ Ý THỨC VƯỢT QUA</a:t>
+            </a:r>
+          </a:p>
+        </p:txBody>
+      </p:sp>
+      <p:sp>
+        <p:nvSpPr>
+          <p:cNvPr id="5" name="Rectangle 4"/>
+          <p:cNvSpPr/>
+          <p:nvPr/>
+        </p:nvSpPr>
+        <p:spPr>
+          <a:xfrm>
+            <a:off x="457200" y="1207008"/>
+            <a:ext cx="11274552" cy="22000"/>
+          </a:xfrm>
+          <a:prstGeom prst="rect">
+            <a:avLst/>
+          </a:prstGeom>
+          <a:solidFill>
+            <a:srgbClr val="E2E8F0"/>
+          </a:solidFill>
+          <a:ln>
+            <a:noFill/>
+          </a:ln>
+          <a:effectLst/>
+        </p:spPr>
+        <p:style>
+          <a:lnRef idx="1">
+            <a:schemeClr val="accent1"/>
+          </a:lnRef>
+          <a:fillRef idx="3">
+            <a:schemeClr val="accent1"/>
+          </a:fillRef>
+          <a:effectRef idx="2">
+            <a:schemeClr val="accent1"/>
+          </a:effectRef>
+          <a:fontRef idx="minor">
+            <a:schemeClr val="lt1"/>
+          </a:fontRef>
+        </p:style>
+        <p:txBody>
+          <a:bodyPr rtlCol="0" anchor="ctr"/>
+          <a:lstStyle/>
+          <a:p>
+            <a:pPr algn="ctr"/>
+          </a:p>
+        </p:txBody>
+      </p:sp>
+      <p:sp>
+        <p:nvSpPr>
+          <p:cNvPr id="6" name="TextBox 5"/>
+          <p:cNvSpPr txBox="1"/>
+          <p:nvPr/>
+        </p:nvSpPr>
+        <p:spPr>
+          <a:xfrm>
+            <a:off x="457200" y="6355080"/>
+            <a:ext cx="11274552" cy="365760"/>
+          </a:xfrm>
+          <a:prstGeom prst="rect">
+            <a:avLst/>
+          </a:prstGeom>
+          <a:noFill/>
+        </p:spPr>
+        <p:txBody>
+          <a:bodyPr wrap="none">
+            <a:spAutoFit/>
+          </a:bodyPr>
+          <a:lstStyle/>
+          <a:p>
+            <a:pPr algn="r"/>
+            <a:r>
+              <a:rPr sz="1200">
+                <a:solidFill>
+                  <a:srgbClr val="64748B"/>
+                </a:solidFill>
+                <a:latin typeface="Calibri"/>
+              </a:rPr>
+              <a:t>Ngữ văn 11 · Bài 2: Cấu Tứ Và Hình Ảnh Trong Thơ Trữ Tình          23</a:t>
+            </a:r>
+          </a:p>
+        </p:txBody>
+      </p:sp>
+      <p:sp>
+        <p:nvSpPr>
+          <p:cNvPr id="7" name="TextBox 6"/>
+          <p:cNvSpPr txBox="1"/>
+          <p:nvPr/>
+        </p:nvSpPr>
+        <p:spPr>
+          <a:xfrm>
+            <a:off x="731520" y="1463040"/>
+            <a:ext cx="10789920" cy="3566160"/>
+          </a:xfrm>
+          <a:prstGeom prst="rect">
+            <a:avLst/>
+          </a:prstGeom>
+          <a:noFill/>
+        </p:spPr>
+        <p:txBody>
+          <a:bodyPr wrap="square" anchor="t" lIns="45720" rIns="45720">
             <a:spAutoFit/>
           </a:bodyPr>
           <a:lstStyle/>
@@ -9931,13 +10174,100 @@
               </a:spcAft>
             </a:pPr>
             <a:r>
-              <a:rPr sz="3600" b="1">
+              <a:rPr sz="2600" b="1">
+                <a:solidFill>
+                  <a:srgbClr val="1E293B"/>
+                </a:solidFill>
+                <a:latin typeface="Calibri"/>
+              </a:rPr>
+              <a:t>Những hình ảnh, âm thanh trong bài thơ diễn tả mâu thuẫn giữa nỗi buồn với ý thức vượt qua trở ngại của nhân vật trữ tình như thế nào?</a:t>
+            </a:r>
+          </a:p>
+        </p:txBody>
+      </p:sp>
+      <p:sp>
+        <p:nvSpPr>
+          <p:cNvPr id="8" name="Rounded Rectangle 7"/>
+          <p:cNvSpPr/>
+          <p:nvPr/>
+        </p:nvSpPr>
+        <p:spPr>
+          <a:xfrm>
+            <a:off x="731520" y="5120640"/>
+            <a:ext cx="10789920" cy="693420"/>
+          </a:xfrm>
+          <a:prstGeom prst="roundRect">
+            <a:avLst>
+              <a:gd name="adj" fmla="val 8000"/>
+            </a:avLst>
+          </a:prstGeom>
+          <a:solidFill>
+            <a:srgbClr val="EFF4FF"/>
+          </a:solidFill>
+          <a:ln w="19050">
+            <a:solidFill>
+              <a:srgbClr val="1E40AF"/>
+            </a:solidFill>
+          </a:ln>
+          <a:effectLst/>
+        </p:spPr>
+        <p:style>
+          <a:lnRef idx="1">
+            <a:schemeClr val="accent1"/>
+          </a:lnRef>
+          <a:fillRef idx="3">
+            <a:schemeClr val="accent1"/>
+          </a:fillRef>
+          <a:effectRef idx="2">
+            <a:schemeClr val="accent1"/>
+          </a:effectRef>
+          <a:fontRef idx="minor">
+            <a:schemeClr val="lt1"/>
+          </a:fontRef>
+        </p:style>
+        <p:txBody>
+          <a:bodyPr rtlCol="0" anchor="ctr"/>
+          <a:lstStyle/>
+          <a:p>
+            <a:pPr algn="ctr"/>
+          </a:p>
+        </p:txBody>
+      </p:sp>
+      <p:sp>
+        <p:nvSpPr>
+          <p:cNvPr id="9" name="TextBox 8"/>
+          <p:cNvSpPr txBox="1"/>
+          <p:nvPr/>
+        </p:nvSpPr>
+        <p:spPr>
+          <a:xfrm>
+            <a:off x="914400" y="5120640"/>
+            <a:ext cx="10424160" cy="693420"/>
+          </a:xfrm>
+          <a:prstGeom prst="rect">
+            <a:avLst/>
+          </a:prstGeom>
+          <a:noFill/>
+        </p:spPr>
+        <p:txBody>
+          <a:bodyPr wrap="square" anchor="ctr" lIns="45720" rIns="45720">
+            <a:spAutoFit/>
+          </a:bodyPr>
+          <a:lstStyle/>
+          <a:p>
+            <a:pPr algn="l">
+              <a:spcAft>
+                <a:spcPts val="400"/>
+              </a:spcAft>
+            </a:pPr>
+            <a:r>
+              <a:rPr sz="2200" b="1">
                 <a:solidFill>
                   <a:srgbClr val="1E40AF"/>
                 </a:solidFill>
                 <a:latin typeface="Calibri"/>
               </a:rPr>
-              <a:t>TIẾT 19: THỰC HÀNH TIẾNG VIỆT</a:t>
+              <a:t>💡 Trăng, cột sọc chỉ đường, tiếng lục lạc, kim đồng hồ…</a:t>
             </a:r>
           </a:p>
         </p:txBody>
@@ -10020,14 +10350,14 @@
         </p:nvSpPr>
         <p:spPr>
           <a:xfrm>
-            <a:off x="10253167" y="457200"/>
-            <a:ext cx="1389888" cy="457200"/>
+            <a:off x="9942271" y="457200"/>
+            <a:ext cx="1700784" cy="457200"/>
           </a:xfrm>
           <a:prstGeom prst="roundRect">
             <a:avLst/>
           </a:prstGeom>
           <a:solidFill>
-            <a:srgbClr val="1E40AF"/>
+            <a:srgbClr val="991B1B"/>
           </a:solidFill>
           <a:ln>
             <a:noFill/>
@@ -10060,7 +10390,7 @@
                 </a:solidFill>
                 <a:latin typeface="Arial"/>
               </a:rPr>
-              <a:t>ĐỀ BÀI</a:t>
+              <a:t>LỜI GIẢI</a:t>
             </a:r>
           </a:p>
         </p:txBody>
@@ -10074,7 +10404,7 @@
         <p:spPr>
           <a:xfrm>
             <a:off x="731520" y="274320"/>
-            <a:ext cx="9582912" cy="868680"/>
+            <a:ext cx="9272016" cy="868680"/>
           </a:xfrm>
           <a:prstGeom prst="rect">
             <a:avLst/>
@@ -10094,7 +10424,7 @@
                 </a:solidFill>
                 <a:latin typeface="Arial"/>
               </a:rPr>
-              <a:t>PHÁ VỠ QUY TẮC NGÔN NGỮ</a:t>
+              <a:t>NỖI BUỒN VÀ Ý THỨC VƯỢT QUA</a:t>
             </a:r>
           </a:p>
         </p:txBody>
@@ -10187,7 +10517,7 @@
         <p:spPr>
           <a:xfrm>
             <a:off x="731520" y="1463040"/>
-            <a:ext cx="10789920" cy="3566160"/>
+            <a:ext cx="10789920" cy="3474720"/>
           </a:xfrm>
           <a:prstGeom prst="rect">
             <a:avLst/>
@@ -10200,19 +10530,66 @@
           </a:bodyPr>
           <a:lstStyle/>
           <a:p>
-            <a:pPr algn="l">
+            <a:pPr algn="l" marL="365760" indent="-365760">
               <a:spcAft>
                 <a:spcPts val="800"/>
               </a:spcAft>
+              <a:buClr>
+                <a:srgbClr val="1E40AF"/>
+              </a:buClr>
+              <a:buFont typeface="Arial"/>
+              <a:buChar char="•"/>
             </a:pPr>
             <a:r>
-              <a:rPr sz="2600" b="1">
+              <a:rPr sz="2300">
                 <a:solidFill>
                   <a:srgbClr val="1E293B"/>
                 </a:solidFill>
                 <a:latin typeface="Calibri"/>
               </a:rPr>
-              <a:t>Chỉ ra nét độc đáo trong kết hợp từ “buồn điệp điệp” và cụm từ “sâu chót vót” trong Tràng giang.</a:t>
+              <a:t>Trăng buồn, đường vắng, tiếng lục lạc đơn điệu – nỗi buồn.</a:t>
+            </a:r>
+          </a:p>
+          <a:p>
+            <a:pPr algn="l" marL="365760" indent="-365760">
+              <a:spcAft>
+                <a:spcPts val="800"/>
+              </a:spcAft>
+              <a:buClr>
+                <a:srgbClr val="1E40AF"/>
+              </a:buClr>
+              <a:buFont typeface="Arial"/>
+              <a:buChar char="•"/>
+            </a:pPr>
+            <a:r>
+              <a:rPr sz="2300">
+                <a:solidFill>
+                  <a:srgbClr val="1E293B"/>
+                </a:solidFill>
+                <a:latin typeface="Calibri"/>
+              </a:rPr>
+              <a:t>Xe tam mã lao nhanh, cột sọc chỉ đường – hành trình tiếp diễn.</a:t>
+            </a:r>
+          </a:p>
+          <a:p>
+            <a:pPr algn="l" marL="365760" indent="-365760">
+              <a:spcAft>
+                <a:spcPts val="800"/>
+              </a:spcAft>
+              <a:buClr>
+                <a:srgbClr val="1E40AF"/>
+              </a:buClr>
+              <a:buFont typeface="Arial"/>
+              <a:buChar char="•"/>
+            </a:pPr>
+            <a:r>
+              <a:rPr sz="2300">
+                <a:solidFill>
+                  <a:srgbClr val="1E293B"/>
+                </a:solidFill>
+                <a:latin typeface="Calibri"/>
+              </a:rPr>
+              <a:t>Tâm tưởng: Nhi-na, lò lửa đỏ – hơi ấm phía trước.</a:t>
             </a:r>
           </a:p>
         </p:txBody>
@@ -10225,8 +10602,8 @@
         </p:nvSpPr>
         <p:spPr>
           <a:xfrm>
-            <a:off x="731520" y="5120640"/>
-            <a:ext cx="10789920" cy="693420"/>
+            <a:off x="731520" y="5074920"/>
+            <a:ext cx="10789920" cy="731520"/>
           </a:xfrm>
           <a:prstGeom prst="roundRect">
             <a:avLst>
@@ -10234,11 +10611,11 @@
             </a:avLst>
           </a:prstGeom>
           <a:solidFill>
-            <a:srgbClr val="EFF4FF"/>
+            <a:srgbClr val="FEF2F2"/>
           </a:solidFill>
           <a:ln w="19050">
             <a:solidFill>
-              <a:srgbClr val="1E40AF"/>
+              <a:srgbClr val="991B1B"/>
             </a:solidFill>
           </a:ln>
           <a:effectLst/>
@@ -10273,8 +10650,8 @@
         </p:nvSpPr>
         <p:spPr>
           <a:xfrm>
-            <a:off x="914400" y="5120640"/>
-            <a:ext cx="10424160" cy="693420"/>
+            <a:off x="914400" y="5074920"/>
+            <a:ext cx="10424160" cy="731520"/>
           </a:xfrm>
           <a:prstGeom prst="rect">
             <a:avLst/>
@@ -10293,13 +10670,13 @@
               </a:spcAft>
             </a:pPr>
             <a:r>
-              <a:rPr sz="2200" b="1">
-                <a:solidFill>
-                  <a:srgbClr val="1E40AF"/>
+              <a:rPr sz="2400" b="1">
+                <a:solidFill>
+                  <a:srgbClr val="991B1B"/>
                 </a:solidFill>
                 <a:latin typeface="Calibri"/>
               </a:rPr>
-              <a:t>💡 Thông thường “điệp điệp”, “chót vót” đi với từ nào?</a:t>
+              <a:t>Không chìm trong u buồn, luôn hướng tới niềm vui.</a:t>
             </a:r>
           </a:p>
         </p:txBody>
@@ -10313,6 +10690,115 @@
 </file>
 
 <file path=ppt/slides/slide25.xml><?xml version="1.0" encoding="utf-8"?>
+<p:sld xmlns:a="http://schemas.openxmlformats.org/drawingml/2006/main" xmlns:p="http://schemas.openxmlformats.org/presentationml/2006/main" xmlns:r="http://schemas.openxmlformats.org/officeDocument/2006/relationships">
+  <p:cSld>
+    <p:bg>
+      <p:bgPr>
+        <a:solidFill>
+          <a:srgbClr val="F8F9FA"/>
+        </a:solidFill>
+        <a:effectLst/>
+      </p:bgPr>
+    </p:bg>
+    <p:spTree>
+      <p:nvGrpSpPr>
+        <p:cNvPr id="1" name=""/>
+        <p:cNvGrpSpPr/>
+        <p:nvPr/>
+      </p:nvGrpSpPr>
+      <p:grpSpPr/>
+      <p:sp>
+        <p:nvSpPr>
+          <p:cNvPr id="2" name="Rectangle 1"/>
+          <p:cNvSpPr/>
+          <p:nvPr/>
+        </p:nvSpPr>
+        <p:spPr>
+          <a:xfrm>
+            <a:off x="548640" y="2926080"/>
+            <a:ext cx="164592" cy="1005840"/>
+          </a:xfrm>
+          <a:prstGeom prst="rect">
+            <a:avLst/>
+          </a:prstGeom>
+          <a:solidFill>
+            <a:srgbClr val="991B1B"/>
+          </a:solidFill>
+          <a:ln>
+            <a:noFill/>
+          </a:ln>
+          <a:effectLst/>
+        </p:spPr>
+        <p:style>
+          <a:lnRef idx="1">
+            <a:schemeClr val="accent1"/>
+          </a:lnRef>
+          <a:fillRef idx="3">
+            <a:schemeClr val="accent1"/>
+          </a:fillRef>
+          <a:effectRef idx="2">
+            <a:schemeClr val="accent1"/>
+          </a:effectRef>
+          <a:fontRef idx="minor">
+            <a:schemeClr val="lt1"/>
+          </a:fontRef>
+        </p:style>
+        <p:txBody>
+          <a:bodyPr rtlCol="0" anchor="ctr"/>
+          <a:lstStyle/>
+          <a:p>
+            <a:pPr algn="ctr"/>
+          </a:p>
+        </p:txBody>
+      </p:sp>
+      <p:sp>
+        <p:nvSpPr>
+          <p:cNvPr id="3" name="TextBox 2"/>
+          <p:cNvSpPr txBox="1"/>
+          <p:nvPr/>
+        </p:nvSpPr>
+        <p:spPr>
+          <a:xfrm>
+            <a:off x="914400" y="2743200"/>
+            <a:ext cx="10515600" cy="1371600"/>
+          </a:xfrm>
+          <a:prstGeom prst="rect">
+            <a:avLst/>
+          </a:prstGeom>
+          <a:noFill/>
+        </p:spPr>
+        <p:txBody>
+          <a:bodyPr wrap="square" anchor="ctr" lIns="45720" rIns="45720">
+            <a:spAutoFit/>
+          </a:bodyPr>
+          <a:lstStyle/>
+          <a:p>
+            <a:pPr algn="l">
+              <a:spcAft>
+                <a:spcPts val="800"/>
+              </a:spcAft>
+            </a:pPr>
+            <a:r>
+              <a:rPr sz="3600" b="1">
+                <a:solidFill>
+                  <a:srgbClr val="1E40AF"/>
+                </a:solidFill>
+                <a:latin typeface="Calibri"/>
+              </a:rPr>
+              <a:t>TIẾT 19: THỰC HÀNH TIẾNG VIỆT</a:t>
+            </a:r>
+          </a:p>
+        </p:txBody>
+      </p:sp>
+    </p:spTree>
+  </p:cSld>
+  <p:clrMapOvr>
+    <a:masterClrMapping/>
+  </p:clrMapOvr>
+</p:sld>
+</file>
+
+<file path=ppt/slides/slide26.xml><?xml version="1.0" encoding="utf-8"?>
 <p:sld xmlns:a="http://schemas.openxmlformats.org/drawingml/2006/main" xmlns:p="http://schemas.openxmlformats.org/presentationml/2006/main" xmlns:r="http://schemas.openxmlformats.org/officeDocument/2006/relationships">
   <p:cSld>
     <p:bg>
@@ -10382,14 +10868,14 @@
         </p:nvSpPr>
         <p:spPr>
           <a:xfrm>
-            <a:off x="9942271" y="457200"/>
-            <a:ext cx="1700784" cy="457200"/>
+            <a:off x="10253167" y="457200"/>
+            <a:ext cx="1389888" cy="457200"/>
           </a:xfrm>
           <a:prstGeom prst="roundRect">
             <a:avLst/>
           </a:prstGeom>
           <a:solidFill>
-            <a:srgbClr val="991B1B"/>
+            <a:srgbClr val="1E40AF"/>
           </a:solidFill>
           <a:ln>
             <a:noFill/>
@@ -10422,7 +10908,7 @@
                 </a:solidFill>
                 <a:latin typeface="Arial"/>
               </a:rPr>
-              <a:t>LỜI GIẢI</a:t>
+              <a:t>ĐỀ BÀI</a:t>
             </a:r>
           </a:p>
         </p:txBody>
@@ -10436,7 +10922,7 @@
         <p:spPr>
           <a:xfrm>
             <a:off x="731520" y="274320"/>
-            <a:ext cx="9272016" cy="868680"/>
+            <a:ext cx="9582912" cy="868680"/>
           </a:xfrm>
           <a:prstGeom prst="rect">
             <a:avLst/>
@@ -10535,7 +11021,7 @@
                 </a:solidFill>
                 <a:latin typeface="Calibri"/>
               </a:rPr>
-              <a:t>Ngữ văn 11 · Bài 2: Cấu Tứ Và Hình Ảnh Trong Thơ Trữ Tình          25</a:t>
+              <a:t>Ngữ văn 11 · Bài 2: Cấu Tứ Và Hình Ảnh Trong Thơ Trữ Tình          26</a:t>
             </a:r>
           </a:p>
         </p:txBody>
@@ -10549,7 +11035,7 @@
         <p:spPr>
           <a:xfrm>
             <a:off x="731520" y="1463040"/>
-            <a:ext cx="10789920" cy="3474720"/>
+            <a:ext cx="10789920" cy="3566160"/>
           </a:xfrm>
           <a:prstGeom prst="rect">
             <a:avLst/>
@@ -10562,66 +11048,19 @@
           </a:bodyPr>
           <a:lstStyle/>
           <a:p>
-            <a:pPr algn="l" marL="365760" indent="-365760">
+            <a:pPr algn="l">
               <a:spcAft>
                 <a:spcPts val="800"/>
               </a:spcAft>
-              <a:buClr>
-                <a:srgbClr val="1E40AF"/>
-              </a:buClr>
-              <a:buFont typeface="Arial"/>
-              <a:buChar char="•"/>
             </a:pPr>
             <a:r>
-              <a:rPr sz="2300">
+              <a:rPr sz="2600" b="1">
                 <a:solidFill>
                   <a:srgbClr val="1E293B"/>
                 </a:solidFill>
                 <a:latin typeface="Calibri"/>
               </a:rPr>
-              <a:t>“trùng trùng điệp điệp” – chỉ sự vật; ghép với “buồn” → nỗi buồn chồng chất.</a:t>
-            </a:r>
-          </a:p>
-          <a:p>
-            <a:pPr algn="l" marL="365760" indent="-365760">
-              <a:spcAft>
-                <a:spcPts val="800"/>
-              </a:spcAft>
-              <a:buClr>
-                <a:srgbClr val="1E40AF"/>
-              </a:buClr>
-              <a:buFont typeface="Arial"/>
-              <a:buChar char="•"/>
-            </a:pPr>
-            <a:r>
-              <a:rPr sz="2300">
-                <a:solidFill>
-                  <a:srgbClr val="1E293B"/>
-                </a:solidFill>
-                <a:latin typeface="Calibri"/>
-              </a:rPr>
-              <a:t>“sâu” (chiều thẳm) + “chót vót” (chiều cao) → kết hợp lạ.</a:t>
-            </a:r>
-          </a:p>
-          <a:p>
-            <a:pPr algn="l" marL="365760" indent="-365760">
-              <a:spcAft>
-                <a:spcPts val="800"/>
-              </a:spcAft>
-              <a:buClr>
-                <a:srgbClr val="1E40AF"/>
-              </a:buClr>
-              <a:buFont typeface="Arial"/>
-              <a:buChar char="•"/>
-            </a:pPr>
-            <a:r>
-              <a:rPr sz="2300">
-                <a:solidFill>
-                  <a:srgbClr val="1E293B"/>
-                </a:solidFill>
-                <a:latin typeface="Calibri"/>
-              </a:rPr>
-              <a:t>Mở rộng không gian ba chiều, nỗi buồn thăm thẳm.</a:t>
+              <a:t>Chỉ ra nét độc đáo trong kết hợp từ “buồn điệp điệp” và cụm từ “sâu chót vót” trong Tràng giang.</a:t>
             </a:r>
           </a:p>
         </p:txBody>
@@ -10634,8 +11073,8 @@
         </p:nvSpPr>
         <p:spPr>
           <a:xfrm>
-            <a:off x="731520" y="5074920"/>
-            <a:ext cx="10789920" cy="731520"/>
+            <a:off x="731520" y="5120640"/>
+            <a:ext cx="10789920" cy="693420"/>
           </a:xfrm>
           <a:prstGeom prst="roundRect">
             <a:avLst>
@@ -10643,11 +11082,11 @@
             </a:avLst>
           </a:prstGeom>
           <a:solidFill>
-            <a:srgbClr val="FEF2F2"/>
+            <a:srgbClr val="EFF4FF"/>
           </a:solidFill>
           <a:ln w="19050">
             <a:solidFill>
-              <a:srgbClr val="991B1B"/>
+              <a:srgbClr val="1E40AF"/>
             </a:solidFill>
           </a:ln>
           <a:effectLst/>
@@ -10682,8 +11121,8 @@
         </p:nvSpPr>
         <p:spPr>
           <a:xfrm>
-            <a:off x="914400" y="5074920"/>
-            <a:ext cx="10424160" cy="731520"/>
+            <a:off x="914400" y="5120640"/>
+            <a:ext cx="10424160" cy="693420"/>
           </a:xfrm>
           <a:prstGeom prst="rect">
             <a:avLst/>
@@ -10702,122 +11141,13 @@
               </a:spcAft>
             </a:pPr>
             <a:r>
-              <a:rPr sz="2400" b="1">
-                <a:solidFill>
-                  <a:srgbClr val="991B1B"/>
+              <a:rPr sz="2200" b="1">
+                <a:solidFill>
+                  <a:srgbClr val="1E40AF"/>
                 </a:solidFill>
                 <a:latin typeface="Calibri"/>
               </a:rPr>
-              <a:t>Phá vỡ quy tắc để “lạ hoá”, tăng sức gợi.</a:t>
-            </a:r>
-          </a:p>
-        </p:txBody>
-      </p:sp>
-    </p:spTree>
-  </p:cSld>
-  <p:clrMapOvr>
-    <a:masterClrMapping/>
-  </p:clrMapOvr>
-</p:sld>
-</file>
-
-<file path=ppt/slides/slide26.xml><?xml version="1.0" encoding="utf-8"?>
-<p:sld xmlns:a="http://schemas.openxmlformats.org/drawingml/2006/main" xmlns:p="http://schemas.openxmlformats.org/presentationml/2006/main" xmlns:r="http://schemas.openxmlformats.org/officeDocument/2006/relationships">
-  <p:cSld>
-    <p:bg>
-      <p:bgPr>
-        <a:solidFill>
-          <a:srgbClr val="F8F9FA"/>
-        </a:solidFill>
-        <a:effectLst/>
-      </p:bgPr>
-    </p:bg>
-    <p:spTree>
-      <p:nvGrpSpPr>
-        <p:cNvPr id="1" name=""/>
-        <p:cNvGrpSpPr/>
-        <p:nvPr/>
-      </p:nvGrpSpPr>
-      <p:grpSpPr/>
-      <p:sp>
-        <p:nvSpPr>
-          <p:cNvPr id="2" name="Rectangle 1"/>
-          <p:cNvSpPr/>
-          <p:nvPr/>
-        </p:nvSpPr>
-        <p:spPr>
-          <a:xfrm>
-            <a:off x="548640" y="2926080"/>
-            <a:ext cx="164592" cy="1005840"/>
-          </a:xfrm>
-          <a:prstGeom prst="rect">
-            <a:avLst/>
-          </a:prstGeom>
-          <a:solidFill>
-            <a:srgbClr val="991B1B"/>
-          </a:solidFill>
-          <a:ln>
-            <a:noFill/>
-          </a:ln>
-          <a:effectLst/>
-        </p:spPr>
-        <p:style>
-          <a:lnRef idx="1">
-            <a:schemeClr val="accent1"/>
-          </a:lnRef>
-          <a:fillRef idx="3">
-            <a:schemeClr val="accent1"/>
-          </a:fillRef>
-          <a:effectRef idx="2">
-            <a:schemeClr val="accent1"/>
-          </a:effectRef>
-          <a:fontRef idx="minor">
-            <a:schemeClr val="lt1"/>
-          </a:fontRef>
-        </p:style>
-        <p:txBody>
-          <a:bodyPr rtlCol="0" anchor="ctr"/>
-          <a:lstStyle/>
-          <a:p>
-            <a:pPr algn="ctr"/>
-          </a:p>
-        </p:txBody>
-      </p:sp>
-      <p:sp>
-        <p:nvSpPr>
-          <p:cNvPr id="3" name="TextBox 2"/>
-          <p:cNvSpPr txBox="1"/>
-          <p:nvPr/>
-        </p:nvSpPr>
-        <p:spPr>
-          <a:xfrm>
-            <a:off x="914400" y="2743200"/>
-            <a:ext cx="10515600" cy="1371600"/>
-          </a:xfrm>
-          <a:prstGeom prst="rect">
-            <a:avLst/>
-          </a:prstGeom>
-          <a:noFill/>
-        </p:spPr>
-        <p:txBody>
-          <a:bodyPr wrap="square" anchor="ctr" lIns="45720" rIns="45720">
-            <a:spAutoFit/>
-          </a:bodyPr>
-          <a:lstStyle/>
-          <a:p>
-            <a:pPr algn="l">
-              <a:spcAft>
-                <a:spcPts val="800"/>
-              </a:spcAft>
-            </a:pPr>
-            <a:r>
-              <a:rPr sz="3600" b="1">
-                <a:solidFill>
-                  <a:srgbClr val="1E40AF"/>
-                </a:solidFill>
-                <a:latin typeface="Calibri"/>
-              </a:rPr>
-              <a:t>TIẾT 20 – 22: VIẾT – NÓI VÀ NGHE</a:t>
+              <a:t>💡 Thông thường “điệp điệp”, “chót vót” đi với từ nào?</a:t>
             </a:r>
           </a:p>
         </p:txBody>
@@ -10900,14 +11230,14 @@
         </p:nvSpPr>
         <p:spPr>
           <a:xfrm>
-            <a:off x="10097719" y="457200"/>
-            <a:ext cx="1545336" cy="457200"/>
+            <a:off x="9942271" y="457200"/>
+            <a:ext cx="1700784" cy="457200"/>
           </a:xfrm>
           <a:prstGeom prst="roundRect">
             <a:avLst/>
           </a:prstGeom>
           <a:solidFill>
-            <a:srgbClr val="166534"/>
+            <a:srgbClr val="991B1B"/>
           </a:solidFill>
           <a:ln>
             <a:noFill/>
@@ -10940,7 +11270,7 @@
                 </a:solidFill>
                 <a:latin typeface="Arial"/>
               </a:rPr>
-              <a:t>GHI NHỚ</a:t>
+              <a:t>LỜI GIẢI</a:t>
             </a:r>
           </a:p>
         </p:txBody>
@@ -10954,7 +11284,7 @@
         <p:spPr>
           <a:xfrm>
             <a:off x="731520" y="274320"/>
-            <a:ext cx="9427464" cy="868680"/>
+            <a:ext cx="9272016" cy="868680"/>
           </a:xfrm>
           <a:prstGeom prst="rect">
             <a:avLst/>
@@ -10974,7 +11304,7 @@
                 </a:solidFill>
                 <a:latin typeface="Arial"/>
               </a:rPr>
-              <a:t>YÊU CẦU BÀI VIẾT</a:t>
+              <a:t>PHÁ VỠ QUY TẮC NGÔN NGỮ</a:t>
             </a:r>
           </a:p>
         </p:txBody>
@@ -11067,7 +11397,7 @@
         <p:spPr>
           <a:xfrm>
             <a:off x="731520" y="1463040"/>
-            <a:ext cx="10789920" cy="4754880"/>
+            <a:ext cx="10789920" cy="3474720"/>
           </a:xfrm>
           <a:prstGeom prst="rect">
             <a:avLst/>
@@ -11091,13 +11421,13 @@
               <a:buChar char="•"/>
             </a:pPr>
             <a:r>
-              <a:rPr sz="2400">
+              <a:rPr sz="2300">
                 <a:solidFill>
                   <a:srgbClr val="1E293B"/>
                 </a:solidFill>
                 <a:latin typeface="Calibri"/>
               </a:rPr>
-              <a:t>Giới thiệu bài thơ, lí do chọn.</a:t>
+              <a:t>“trùng trùng điệp điệp” – chỉ sự vật; ghép với “buồn” → nỗi buồn chồng chất.</a:t>
             </a:r>
           </a:p>
           <a:p>
@@ -11112,13 +11442,13 @@
               <a:buChar char="•"/>
             </a:pPr>
             <a:r>
-              <a:rPr sz="2400">
+              <a:rPr sz="2300">
                 <a:solidFill>
                   <a:srgbClr val="1E293B"/>
                 </a:solidFill>
                 <a:latin typeface="Calibri"/>
               </a:rPr>
-              <a:t>Xác định trọng tâm: cấu tứ độc đáo, sự chi phối tới hệ thống hình ảnh.</a:t>
+              <a:t>“sâu” (chiều thẳm) + “chót vót” (chiều cao) → kết hợp lạ.</a:t>
             </a:r>
           </a:p>
           <a:p>
@@ -11133,34 +11463,100 @@
               <a:buChar char="•"/>
             </a:pPr>
             <a:r>
-              <a:rPr sz="2400">
+              <a:rPr sz="2300">
                 <a:solidFill>
                   <a:srgbClr val="1E293B"/>
                 </a:solidFill>
                 <a:latin typeface="Calibri"/>
               </a:rPr>
-              <a:t>Lí lẽ, bằng chứng xác đáng; nêu hàm nghĩa thận trọng.</a:t>
-            </a:r>
-          </a:p>
-          <a:p>
-            <a:pPr algn="l" marL="365760" indent="-365760">
+              <a:t>Mở rộng không gian ba chiều, nỗi buồn thăm thẳm.</a:t>
+            </a:r>
+          </a:p>
+        </p:txBody>
+      </p:sp>
+      <p:sp>
+        <p:nvSpPr>
+          <p:cNvPr id="8" name="Rounded Rectangle 7"/>
+          <p:cNvSpPr/>
+          <p:nvPr/>
+        </p:nvSpPr>
+        <p:spPr>
+          <a:xfrm>
+            <a:off x="731520" y="5074920"/>
+            <a:ext cx="10789920" cy="731520"/>
+          </a:xfrm>
+          <a:prstGeom prst="roundRect">
+            <a:avLst>
+              <a:gd name="adj" fmla="val 8000"/>
+            </a:avLst>
+          </a:prstGeom>
+          <a:solidFill>
+            <a:srgbClr val="FEF2F2"/>
+          </a:solidFill>
+          <a:ln w="19050">
+            <a:solidFill>
+              <a:srgbClr val="991B1B"/>
+            </a:solidFill>
+          </a:ln>
+          <a:effectLst/>
+        </p:spPr>
+        <p:style>
+          <a:lnRef idx="1">
+            <a:schemeClr val="accent1"/>
+          </a:lnRef>
+          <a:fillRef idx="3">
+            <a:schemeClr val="accent1"/>
+          </a:fillRef>
+          <a:effectRef idx="2">
+            <a:schemeClr val="accent1"/>
+          </a:effectRef>
+          <a:fontRef idx="minor">
+            <a:schemeClr val="lt1"/>
+          </a:fontRef>
+        </p:style>
+        <p:txBody>
+          <a:bodyPr rtlCol="0" anchor="ctr"/>
+          <a:lstStyle/>
+          <a:p>
+            <a:pPr algn="ctr"/>
+          </a:p>
+        </p:txBody>
+      </p:sp>
+      <p:sp>
+        <p:nvSpPr>
+          <p:cNvPr id="9" name="TextBox 8"/>
+          <p:cNvSpPr txBox="1"/>
+          <p:nvPr/>
+        </p:nvSpPr>
+        <p:spPr>
+          <a:xfrm>
+            <a:off x="914400" y="5074920"/>
+            <a:ext cx="10424160" cy="731520"/>
+          </a:xfrm>
+          <a:prstGeom prst="rect">
+            <a:avLst/>
+          </a:prstGeom>
+          <a:noFill/>
+        </p:spPr>
+        <p:txBody>
+          <a:bodyPr wrap="square" anchor="ctr" lIns="45720" rIns="45720">
+            <a:spAutoFit/>
+          </a:bodyPr>
+          <a:lstStyle/>
+          <a:p>
+            <a:pPr algn="l">
               <a:spcAft>
-                <a:spcPts val="800"/>
+                <a:spcPts val="400"/>
               </a:spcAft>
-              <a:buClr>
-                <a:srgbClr val="1E40AF"/>
-              </a:buClr>
-              <a:buFont typeface="Arial"/>
-              <a:buChar char="•"/>
             </a:pPr>
             <a:r>
-              <a:rPr sz="2400">
-                <a:solidFill>
-                  <a:srgbClr val="1E293B"/>
+              <a:rPr sz="2400" b="1">
+                <a:solidFill>
+                  <a:srgbClr val="991B1B"/>
                 </a:solidFill>
                 <a:latin typeface="Calibri"/>
               </a:rPr>
-              <a:t>Đánh giá giá trị cấu tứ, hình ảnh.</a:t>
+              <a:t>Phá vỡ quy tắc để “lạ hoá”, tăng sức gợi.</a:t>
             </a:r>
           </a:p>
         </p:txBody>
@@ -11179,7 +11575,7 @@
     <p:bg>
       <p:bgPr>
         <a:solidFill>
-          <a:srgbClr val="FFFFFF"/>
+          <a:srgbClr val="F8F9FA"/>
         </a:solidFill>
         <a:effectLst/>
       </p:bgPr>
@@ -11199,14 +11595,14 @@
         </p:nvSpPr>
         <p:spPr>
           <a:xfrm>
-            <a:off x="457200" y="384048"/>
-            <a:ext cx="109728" cy="658368"/>
+            <a:off x="548640" y="2926080"/>
+            <a:ext cx="164592" cy="1005840"/>
           </a:xfrm>
           <a:prstGeom prst="rect">
             <a:avLst/>
           </a:prstGeom>
           <a:solidFill>
-            <a:srgbClr val="1E40AF"/>
+            <a:srgbClr val="991B1B"/>
           </a:solidFill>
           <a:ln>
             <a:noFill/>
@@ -11237,67 +11633,14 @@
       </p:sp>
       <p:sp>
         <p:nvSpPr>
-          <p:cNvPr id="3" name="Rounded Rectangle 2"/>
-          <p:cNvSpPr/>
-          <p:nvPr/>
-        </p:nvSpPr>
-        <p:spPr>
-          <a:xfrm>
-            <a:off x="10253167" y="457200"/>
-            <a:ext cx="1389888" cy="457200"/>
-          </a:xfrm>
-          <a:prstGeom prst="roundRect">
-            <a:avLst/>
-          </a:prstGeom>
-          <a:solidFill>
-            <a:srgbClr val="1E40AF"/>
-          </a:solidFill>
-          <a:ln>
-            <a:noFill/>
-          </a:ln>
-          <a:effectLst/>
-        </p:spPr>
-        <p:style>
-          <a:lnRef idx="1">
-            <a:schemeClr val="accent1"/>
-          </a:lnRef>
-          <a:fillRef idx="3">
-            <a:schemeClr val="accent1"/>
-          </a:fillRef>
-          <a:effectRef idx="2">
-            <a:schemeClr val="accent1"/>
-          </a:effectRef>
-          <a:fontRef idx="minor">
-            <a:schemeClr val="lt1"/>
-          </a:fontRef>
-        </p:style>
-        <p:txBody>
-          <a:bodyPr rtlCol="0" anchor="ctr" wrap="none" tIns="0" bIns="0"/>
-          <a:lstStyle/>
-          <a:p>
-            <a:pPr algn="ctr"/>
-            <a:r>
-              <a:rPr sz="1400" b="1">
-                <a:solidFill>
-                  <a:srgbClr val="FFFFFF"/>
-                </a:solidFill>
-                <a:latin typeface="Arial"/>
-              </a:rPr>
-              <a:t>ĐỀ BÀI</a:t>
-            </a:r>
-          </a:p>
-        </p:txBody>
-      </p:sp>
-      <p:sp>
-        <p:nvSpPr>
-          <p:cNvPr id="4" name="TextBox 3"/>
+          <p:cNvPr id="3" name="TextBox 2"/>
           <p:cNvSpPr txBox="1"/>
           <p:nvPr/>
         </p:nvSpPr>
         <p:spPr>
           <a:xfrm>
-            <a:off x="731520" y="274320"/>
-            <a:ext cx="9582912" cy="868680"/>
+            <a:off x="914400" y="2743200"/>
+            <a:ext cx="10515600" cy="1371600"/>
           </a:xfrm>
           <a:prstGeom prst="rect">
             <a:avLst/>
@@ -11305,120 +11648,7 @@
           <a:noFill/>
         </p:spPr>
         <p:txBody>
-          <a:bodyPr wrap="square" anchor="ctr">
-            <a:spAutoFit/>
-          </a:bodyPr>
-          <a:lstStyle/>
-          <a:p>
-            <a:r>
-              <a:rPr sz="3600" b="1">
-                <a:solidFill>
-                  <a:srgbClr val="1E40AF"/>
-                </a:solidFill>
-                <a:latin typeface="Arial"/>
-              </a:rPr>
-              <a:t>ĐỀ THỰC HÀNH VIẾT</a:t>
-            </a:r>
-          </a:p>
-        </p:txBody>
-      </p:sp>
-      <p:sp>
-        <p:nvSpPr>
-          <p:cNvPr id="5" name="Rectangle 4"/>
-          <p:cNvSpPr/>
-          <p:nvPr/>
-        </p:nvSpPr>
-        <p:spPr>
-          <a:xfrm>
-            <a:off x="457200" y="1207008"/>
-            <a:ext cx="11274552" cy="22000"/>
-          </a:xfrm>
-          <a:prstGeom prst="rect">
-            <a:avLst/>
-          </a:prstGeom>
-          <a:solidFill>
-            <a:srgbClr val="E2E8F0"/>
-          </a:solidFill>
-          <a:ln>
-            <a:noFill/>
-          </a:ln>
-          <a:effectLst/>
-        </p:spPr>
-        <p:style>
-          <a:lnRef idx="1">
-            <a:schemeClr val="accent1"/>
-          </a:lnRef>
-          <a:fillRef idx="3">
-            <a:schemeClr val="accent1"/>
-          </a:fillRef>
-          <a:effectRef idx="2">
-            <a:schemeClr val="accent1"/>
-          </a:effectRef>
-          <a:fontRef idx="minor">
-            <a:schemeClr val="lt1"/>
-          </a:fontRef>
-        </p:style>
-        <p:txBody>
-          <a:bodyPr rtlCol="0" anchor="ctr"/>
-          <a:lstStyle/>
-          <a:p>
-            <a:pPr algn="ctr"/>
-          </a:p>
-        </p:txBody>
-      </p:sp>
-      <p:sp>
-        <p:nvSpPr>
-          <p:cNvPr id="6" name="TextBox 5"/>
-          <p:cNvSpPr txBox="1"/>
-          <p:nvPr/>
-        </p:nvSpPr>
-        <p:spPr>
-          <a:xfrm>
-            <a:off x="457200" y="6355080"/>
-            <a:ext cx="11274552" cy="365760"/>
-          </a:xfrm>
-          <a:prstGeom prst="rect">
-            <a:avLst/>
-          </a:prstGeom>
-          <a:noFill/>
-        </p:spPr>
-        <p:txBody>
-          <a:bodyPr wrap="none">
-            <a:spAutoFit/>
-          </a:bodyPr>
-          <a:lstStyle/>
-          <a:p>
-            <a:pPr algn="r"/>
-            <a:r>
-              <a:rPr sz="1200">
-                <a:solidFill>
-                  <a:srgbClr val="64748B"/>
-                </a:solidFill>
-                <a:latin typeface="Calibri"/>
-              </a:rPr>
-              <a:t>Ngữ văn 11 · Bài 2: Cấu Tứ Và Hình Ảnh Trong Thơ Trữ Tình          28</a:t>
-            </a:r>
-          </a:p>
-        </p:txBody>
-      </p:sp>
-      <p:sp>
-        <p:nvSpPr>
-          <p:cNvPr id="7" name="TextBox 6"/>
-          <p:cNvSpPr txBox="1"/>
-          <p:nvPr/>
-        </p:nvSpPr>
-        <p:spPr>
-          <a:xfrm>
-            <a:off x="731520" y="1463040"/>
-            <a:ext cx="10789920" cy="3566160"/>
-          </a:xfrm>
-          <a:prstGeom prst="rect">
-            <a:avLst/>
-          </a:prstGeom>
-          <a:noFill/>
-        </p:spPr>
-        <p:txBody>
-          <a:bodyPr wrap="square" anchor="t" lIns="45720" rIns="45720">
+          <a:bodyPr wrap="square" anchor="ctr" lIns="45720" rIns="45720">
             <a:spAutoFit/>
           </a:bodyPr>
           <a:lstStyle/>
@@ -11429,100 +11659,13 @@
               </a:spcAft>
             </a:pPr>
             <a:r>
-              <a:rPr sz="2600" b="1">
-                <a:solidFill>
-                  <a:srgbClr val="1E293B"/>
+              <a:rPr sz="3600" b="1">
+                <a:solidFill>
+                  <a:srgbClr val="1E40AF"/>
                 </a:solidFill>
                 <a:latin typeface="Calibri"/>
               </a:rPr>
-              <a:t>Phân tích cấu tứ và hình ảnh trong bài thơ Tràng giang (Huy Cận).</a:t>
-            </a:r>
-          </a:p>
-        </p:txBody>
-      </p:sp>
-      <p:sp>
-        <p:nvSpPr>
-          <p:cNvPr id="8" name="Rounded Rectangle 7"/>
-          <p:cNvSpPr/>
-          <p:nvPr/>
-        </p:nvSpPr>
-        <p:spPr>
-          <a:xfrm>
-            <a:off x="731520" y="5120640"/>
-            <a:ext cx="10789920" cy="693420"/>
-          </a:xfrm>
-          <a:prstGeom prst="roundRect">
-            <a:avLst>
-              <a:gd name="adj" fmla="val 8000"/>
-            </a:avLst>
-          </a:prstGeom>
-          <a:solidFill>
-            <a:srgbClr val="EFF4FF"/>
-          </a:solidFill>
-          <a:ln w="19050">
-            <a:solidFill>
-              <a:srgbClr val="1E40AF"/>
-            </a:solidFill>
-          </a:ln>
-          <a:effectLst/>
-        </p:spPr>
-        <p:style>
-          <a:lnRef idx="1">
-            <a:schemeClr val="accent1"/>
-          </a:lnRef>
-          <a:fillRef idx="3">
-            <a:schemeClr val="accent1"/>
-          </a:fillRef>
-          <a:effectRef idx="2">
-            <a:schemeClr val="accent1"/>
-          </a:effectRef>
-          <a:fontRef idx="minor">
-            <a:schemeClr val="lt1"/>
-          </a:fontRef>
-        </p:style>
-        <p:txBody>
-          <a:bodyPr rtlCol="0" anchor="ctr"/>
-          <a:lstStyle/>
-          <a:p>
-            <a:pPr algn="ctr"/>
-          </a:p>
-        </p:txBody>
-      </p:sp>
-      <p:sp>
-        <p:nvSpPr>
-          <p:cNvPr id="9" name="TextBox 8"/>
-          <p:cNvSpPr txBox="1"/>
-          <p:nvPr/>
-        </p:nvSpPr>
-        <p:spPr>
-          <a:xfrm>
-            <a:off x="914400" y="5120640"/>
-            <a:ext cx="10424160" cy="693420"/>
-          </a:xfrm>
-          <a:prstGeom prst="rect">
-            <a:avLst/>
-          </a:prstGeom>
-          <a:noFill/>
-        </p:spPr>
-        <p:txBody>
-          <a:bodyPr wrap="square" anchor="ctr" lIns="45720" rIns="45720">
-            <a:spAutoFit/>
-          </a:bodyPr>
-          <a:lstStyle/>
-          <a:p>
-            <a:pPr algn="l">
-              <a:spcAft>
-                <a:spcPts val="400"/>
-              </a:spcAft>
-            </a:pPr>
-            <a:r>
-              <a:rPr sz="2200" b="1">
-                <a:solidFill>
-                  <a:srgbClr val="1E40AF"/>
-                </a:solidFill>
-                <a:latin typeface="Calibri"/>
-              </a:rPr>
-              <a:t>💡 Vẽ sơ đồ cấu tứ trước khi viết.</a:t>
+              <a:t>TIẾT 20 – 22: VIẾT – NÓI VÀ NGHE</a:t>
             </a:r>
           </a:p>
         </p:txBody>
@@ -11605,14 +11748,14 @@
         </p:nvSpPr>
         <p:spPr>
           <a:xfrm>
-            <a:off x="9942271" y="457200"/>
-            <a:ext cx="1700784" cy="457200"/>
+            <a:off x="10097719" y="457200"/>
+            <a:ext cx="1545336" cy="457200"/>
           </a:xfrm>
           <a:prstGeom prst="roundRect">
             <a:avLst/>
           </a:prstGeom>
           <a:solidFill>
-            <a:srgbClr val="991B1B"/>
+            <a:srgbClr val="166534"/>
           </a:solidFill>
           <a:ln>
             <a:noFill/>
@@ -11645,7 +11788,7 @@
                 </a:solidFill>
                 <a:latin typeface="Arial"/>
               </a:rPr>
-              <a:t>LỜI GIẢI</a:t>
+              <a:t>GHI NHỚ</a:t>
             </a:r>
           </a:p>
         </p:txBody>
@@ -11659,7 +11802,7 @@
         <p:spPr>
           <a:xfrm>
             <a:off x="731520" y="274320"/>
-            <a:ext cx="9272016" cy="868680"/>
+            <a:ext cx="9427464" cy="868680"/>
           </a:xfrm>
           <a:prstGeom prst="rect">
             <a:avLst/>
@@ -11679,7 +11822,7 @@
                 </a:solidFill>
                 <a:latin typeface="Arial"/>
               </a:rPr>
-              <a:t>ĐỀ THỰC HÀNH VIẾT</a:t>
+              <a:t>YÊU CẦU BÀI VIẾT</a:t>
             </a:r>
           </a:p>
         </p:txBody>
@@ -11772,7 +11915,7 @@
         <p:spPr>
           <a:xfrm>
             <a:off x="731520" y="1463040"/>
-            <a:ext cx="10789920" cy="3474720"/>
+            <a:ext cx="10789920" cy="4754880"/>
           </a:xfrm>
           <a:prstGeom prst="rect">
             <a:avLst/>
@@ -11796,13 +11939,13 @@
               <a:buChar char="•"/>
             </a:pPr>
             <a:r>
-              <a:rPr sz="2300">
+              <a:rPr sz="2400">
                 <a:solidFill>
                   <a:srgbClr val="1E293B"/>
                 </a:solidFill>
                 <a:latin typeface="Calibri"/>
               </a:rPr>
-              <a:t>MB: giới thiệu, nêu vấn đề.</a:t>
+              <a:t>Giới thiệu bài thơ, lí do chọn.</a:t>
             </a:r>
           </a:p>
           <a:p>
@@ -11817,13 +11960,13 @@
               <a:buChar char="•"/>
             </a:pPr>
             <a:r>
-              <a:rPr sz="2300">
+              <a:rPr sz="2400">
                 <a:solidFill>
                   <a:srgbClr val="1E293B"/>
                 </a:solidFill>
                 <a:latin typeface="Calibri"/>
               </a:rPr>
-              <a:t>TB: nhan đề – đề từ; cấu tứ tương phản qua 4 khổ; hệ thống hình ảnh, thi liệu.</a:t>
+              <a:t>Xác định trọng tâm: cấu tứ độc đáo, sự chi phối tới hệ thống hình ảnh.</a:t>
             </a:r>
           </a:p>
           <a:p>
@@ -11838,13 +11981,13 @@
               <a:buChar char="•"/>
             </a:pPr>
             <a:r>
-              <a:rPr sz="2300">
+              <a:rPr sz="2400">
                 <a:solidFill>
                   <a:srgbClr val="1E293B"/>
                 </a:solidFill>
                 <a:latin typeface="Calibri"/>
               </a:rPr>
-              <a:t>Yếu tố tượng trưng, ngôn ngữ phá cách; đánh giá.</a:t>
+              <a:t>Lí lẽ, bằng chứng xác đáng; nêu hàm nghĩa thận trọng.</a:t>
             </a:r>
           </a:p>
           <a:p>
@@ -11859,100 +12002,13 @@
               <a:buChar char="•"/>
             </a:pPr>
             <a:r>
-              <a:rPr sz="2300">
+              <a:rPr sz="2400">
                 <a:solidFill>
                   <a:srgbClr val="1E293B"/>
                 </a:solidFill>
                 <a:latin typeface="Calibri"/>
               </a:rPr>
-              <a:t>KB: khẳng định giá trị.</a:t>
-            </a:r>
-          </a:p>
-        </p:txBody>
-      </p:sp>
-      <p:sp>
-        <p:nvSpPr>
-          <p:cNvPr id="8" name="Rounded Rectangle 7"/>
-          <p:cNvSpPr/>
-          <p:nvPr/>
-        </p:nvSpPr>
-        <p:spPr>
-          <a:xfrm>
-            <a:off x="731520" y="5074920"/>
-            <a:ext cx="10789920" cy="731520"/>
-          </a:xfrm>
-          <a:prstGeom prst="roundRect">
-            <a:avLst>
-              <a:gd name="adj" fmla="val 8000"/>
-            </a:avLst>
-          </a:prstGeom>
-          <a:solidFill>
-            <a:srgbClr val="FEF2F2"/>
-          </a:solidFill>
-          <a:ln w="19050">
-            <a:solidFill>
-              <a:srgbClr val="991B1B"/>
-            </a:solidFill>
-          </a:ln>
-          <a:effectLst/>
-        </p:spPr>
-        <p:style>
-          <a:lnRef idx="1">
-            <a:schemeClr val="accent1"/>
-          </a:lnRef>
-          <a:fillRef idx="3">
-            <a:schemeClr val="accent1"/>
-          </a:fillRef>
-          <a:effectRef idx="2">
-            <a:schemeClr val="accent1"/>
-          </a:effectRef>
-          <a:fontRef idx="minor">
-            <a:schemeClr val="lt1"/>
-          </a:fontRef>
-        </p:style>
-        <p:txBody>
-          <a:bodyPr rtlCol="0" anchor="ctr"/>
-          <a:lstStyle/>
-          <a:p>
-            <a:pPr algn="ctr"/>
-          </a:p>
-        </p:txBody>
-      </p:sp>
-      <p:sp>
-        <p:nvSpPr>
-          <p:cNvPr id="9" name="TextBox 8"/>
-          <p:cNvSpPr txBox="1"/>
-          <p:nvPr/>
-        </p:nvSpPr>
-        <p:spPr>
-          <a:xfrm>
-            <a:off x="914400" y="5074920"/>
-            <a:ext cx="10424160" cy="731520"/>
-          </a:xfrm>
-          <a:prstGeom prst="rect">
-            <a:avLst/>
-          </a:prstGeom>
-          <a:noFill/>
-        </p:spPr>
-        <p:txBody>
-          <a:bodyPr wrap="square" anchor="ctr" lIns="45720" rIns="45720">
-            <a:spAutoFit/>
-          </a:bodyPr>
-          <a:lstStyle/>
-          <a:p>
-            <a:pPr algn="l">
-              <a:spcAft>
-                <a:spcPts val="400"/>
-              </a:spcAft>
-            </a:pPr>
-            <a:r>
-              <a:rPr sz="2400" b="1">
-                <a:solidFill>
-                  <a:srgbClr val="991B1B"/>
-                </a:solidFill>
-                <a:latin typeface="Calibri"/>
-              </a:rPr>
-              <a:t>Gắn cấu tứ với hệ thống hình ảnh.</a:t>
+              <a:t>Đánh giá giá trị cấu tứ, hình ảnh.</a:t>
             </a:r>
           </a:p>
         </p:txBody>
@@ -12144,14 +12200,14 @@
         </p:nvSpPr>
         <p:spPr>
           <a:xfrm>
-            <a:off x="10097719" y="457200"/>
-            <a:ext cx="1545336" cy="457200"/>
+            <a:off x="10253167" y="457200"/>
+            <a:ext cx="1389888" cy="457200"/>
           </a:xfrm>
           <a:prstGeom prst="roundRect">
             <a:avLst/>
           </a:prstGeom>
           <a:solidFill>
-            <a:srgbClr val="166534"/>
+            <a:srgbClr val="1E40AF"/>
           </a:solidFill>
           <a:ln>
             <a:noFill/>
@@ -12184,7 +12240,7 @@
                 </a:solidFill>
                 <a:latin typeface="Arial"/>
               </a:rPr>
-              <a:t>CỦNG CỐ</a:t>
+              <a:t>ĐỀ BÀI</a:t>
             </a:r>
           </a:p>
         </p:txBody>
@@ -12198,7 +12254,7 @@
         <p:spPr>
           <a:xfrm>
             <a:off x="731520" y="274320"/>
-            <a:ext cx="9427464" cy="868680"/>
+            <a:ext cx="9582912" cy="868680"/>
           </a:xfrm>
           <a:prstGeom prst="rect">
             <a:avLst/>
@@ -12218,7 +12274,7 @@
                 </a:solidFill>
                 <a:latin typeface="Arial"/>
               </a:rPr>
-              <a:t>SƠ ĐỒ TƯ DUY</a:t>
+              <a:t>ĐỀ THỰC HÀNH VIẾT</a:t>
             </a:r>
           </a:p>
         </p:txBody>
@@ -12302,30 +12358,132 @@
           </a:p>
         </p:txBody>
       </p:sp>
-      <p:pic>
-        <p:nvPicPr>
-          <p:cNvPr id="7" name="Picture 6" descr="SoDoTuDuy_NGUVAN11_Bai2_CauTuVaHinhAnhTrongThoTruTinh_T12-22.png"/>
-          <p:cNvPicPr>
-            <a:picLocks noChangeAspect="1"/>
-          </p:cNvPicPr>
-          <p:nvPr/>
-        </p:nvPicPr>
-        <p:blipFill>
-          <a:blip r:embed="rId2"/>
-          <a:stretch>
-            <a:fillRect/>
-          </a:stretch>
-        </p:blipFill>
-        <p:spPr>
-          <a:xfrm>
-            <a:off x="1788855" y="1371600"/>
-            <a:ext cx="8675250" cy="4846320"/>
-          </a:xfrm>
-          <a:prstGeom prst="rect">
-            <a:avLst/>
-          </a:prstGeom>
-        </p:spPr>
-      </p:pic>
+      <p:sp>
+        <p:nvSpPr>
+          <p:cNvPr id="7" name="TextBox 6"/>
+          <p:cNvSpPr txBox="1"/>
+          <p:nvPr/>
+        </p:nvSpPr>
+        <p:spPr>
+          <a:xfrm>
+            <a:off x="731520" y="1463040"/>
+            <a:ext cx="10789920" cy="3566160"/>
+          </a:xfrm>
+          <a:prstGeom prst="rect">
+            <a:avLst/>
+          </a:prstGeom>
+          <a:noFill/>
+        </p:spPr>
+        <p:txBody>
+          <a:bodyPr wrap="square" anchor="t" lIns="45720" rIns="45720">
+            <a:spAutoFit/>
+          </a:bodyPr>
+          <a:lstStyle/>
+          <a:p>
+            <a:pPr algn="l">
+              <a:spcAft>
+                <a:spcPts val="800"/>
+              </a:spcAft>
+            </a:pPr>
+            <a:r>
+              <a:rPr sz="2600" b="1">
+                <a:solidFill>
+                  <a:srgbClr val="1E293B"/>
+                </a:solidFill>
+                <a:latin typeface="Calibri"/>
+              </a:rPr>
+              <a:t>Phân tích cấu tứ và hình ảnh trong bài thơ Tràng giang (Huy Cận).</a:t>
+            </a:r>
+          </a:p>
+        </p:txBody>
+      </p:sp>
+      <p:sp>
+        <p:nvSpPr>
+          <p:cNvPr id="8" name="Rounded Rectangle 7"/>
+          <p:cNvSpPr/>
+          <p:nvPr/>
+        </p:nvSpPr>
+        <p:spPr>
+          <a:xfrm>
+            <a:off x="731520" y="5120640"/>
+            <a:ext cx="10789920" cy="693420"/>
+          </a:xfrm>
+          <a:prstGeom prst="roundRect">
+            <a:avLst>
+              <a:gd name="adj" fmla="val 8000"/>
+            </a:avLst>
+          </a:prstGeom>
+          <a:solidFill>
+            <a:srgbClr val="EFF4FF"/>
+          </a:solidFill>
+          <a:ln w="19050">
+            <a:solidFill>
+              <a:srgbClr val="1E40AF"/>
+            </a:solidFill>
+          </a:ln>
+          <a:effectLst/>
+        </p:spPr>
+        <p:style>
+          <a:lnRef idx="1">
+            <a:schemeClr val="accent1"/>
+          </a:lnRef>
+          <a:fillRef idx="3">
+            <a:schemeClr val="accent1"/>
+          </a:fillRef>
+          <a:effectRef idx="2">
+            <a:schemeClr val="accent1"/>
+          </a:effectRef>
+          <a:fontRef idx="minor">
+            <a:schemeClr val="lt1"/>
+          </a:fontRef>
+        </p:style>
+        <p:txBody>
+          <a:bodyPr rtlCol="0" anchor="ctr"/>
+          <a:lstStyle/>
+          <a:p>
+            <a:pPr algn="ctr"/>
+          </a:p>
+        </p:txBody>
+      </p:sp>
+      <p:sp>
+        <p:nvSpPr>
+          <p:cNvPr id="9" name="TextBox 8"/>
+          <p:cNvSpPr txBox="1"/>
+          <p:nvPr/>
+        </p:nvSpPr>
+        <p:spPr>
+          <a:xfrm>
+            <a:off x="914400" y="5120640"/>
+            <a:ext cx="10424160" cy="693420"/>
+          </a:xfrm>
+          <a:prstGeom prst="rect">
+            <a:avLst/>
+          </a:prstGeom>
+          <a:noFill/>
+        </p:spPr>
+        <p:txBody>
+          <a:bodyPr wrap="square" anchor="ctr" lIns="45720" rIns="45720">
+            <a:spAutoFit/>
+          </a:bodyPr>
+          <a:lstStyle/>
+          <a:p>
+            <a:pPr algn="l">
+              <a:spcAft>
+                <a:spcPts val="400"/>
+              </a:spcAft>
+            </a:pPr>
+            <a:r>
+              <a:rPr sz="2200" b="1">
+                <a:solidFill>
+                  <a:srgbClr val="1E40AF"/>
+                </a:solidFill>
+                <a:latin typeface="Calibri"/>
+              </a:rPr>
+              <a:t>💡 Vẽ sơ đồ cấu tứ trước khi viết.</a:t>
+            </a:r>
+          </a:p>
+        </p:txBody>
+      </p:sp>
     </p:spTree>
   </p:cSld>
   <p:clrMapOvr>
@@ -12404,8 +12562,8 @@
         </p:nvSpPr>
         <p:spPr>
           <a:xfrm>
-            <a:off x="10097719" y="457200"/>
-            <a:ext cx="1545336" cy="457200"/>
+            <a:off x="9942271" y="457200"/>
+            <a:ext cx="1700784" cy="457200"/>
           </a:xfrm>
           <a:prstGeom prst="roundRect">
             <a:avLst/>
@@ -12444,7 +12602,7 @@
                 </a:solidFill>
                 <a:latin typeface="Arial"/>
               </a:rPr>
-              <a:t>CỦNG CỐ</a:t>
+              <a:t>LỜI GIẢI</a:t>
             </a:r>
           </a:p>
         </p:txBody>
@@ -12458,7 +12616,7 @@
         <p:spPr>
           <a:xfrm>
             <a:off x="731520" y="274320"/>
-            <a:ext cx="9427464" cy="868680"/>
+            <a:ext cx="9272016" cy="868680"/>
           </a:xfrm>
           <a:prstGeom prst="rect">
             <a:avLst/>
@@ -12478,7 +12636,7 @@
                 </a:solidFill>
                 <a:latin typeface="Arial"/>
               </a:rPr>
-              <a:t>BÀI TẬP CỦA BẠN</a:t>
+              <a:t>ĐỀ THỰC HÀNH VIẾT</a:t>
             </a:r>
           </a:p>
         </p:txBody>
@@ -12558,6 +12716,696 @@
                 <a:latin typeface="Calibri"/>
               </a:rPr>
               <a:t>Ngữ văn 11 · Bài 2: Cấu Tứ Và Hình Ảnh Trong Thơ Trữ Tình          31</a:t>
+            </a:r>
+          </a:p>
+        </p:txBody>
+      </p:sp>
+      <p:sp>
+        <p:nvSpPr>
+          <p:cNvPr id="7" name="TextBox 6"/>
+          <p:cNvSpPr txBox="1"/>
+          <p:nvPr/>
+        </p:nvSpPr>
+        <p:spPr>
+          <a:xfrm>
+            <a:off x="731520" y="1463040"/>
+            <a:ext cx="10789920" cy="3474720"/>
+          </a:xfrm>
+          <a:prstGeom prst="rect">
+            <a:avLst/>
+          </a:prstGeom>
+          <a:noFill/>
+        </p:spPr>
+        <p:txBody>
+          <a:bodyPr wrap="square" anchor="t" lIns="45720" rIns="45720">
+            <a:spAutoFit/>
+          </a:bodyPr>
+          <a:lstStyle/>
+          <a:p>
+            <a:pPr algn="l" marL="365760" indent="-365760">
+              <a:spcAft>
+                <a:spcPts val="800"/>
+              </a:spcAft>
+              <a:buClr>
+                <a:srgbClr val="1E40AF"/>
+              </a:buClr>
+              <a:buFont typeface="Arial"/>
+              <a:buChar char="•"/>
+            </a:pPr>
+            <a:r>
+              <a:rPr sz="2300">
+                <a:solidFill>
+                  <a:srgbClr val="1E293B"/>
+                </a:solidFill>
+                <a:latin typeface="Calibri"/>
+              </a:rPr>
+              <a:t>MB: giới thiệu, nêu vấn đề.</a:t>
+            </a:r>
+          </a:p>
+          <a:p>
+            <a:pPr algn="l" marL="365760" indent="-365760">
+              <a:spcAft>
+                <a:spcPts val="800"/>
+              </a:spcAft>
+              <a:buClr>
+                <a:srgbClr val="1E40AF"/>
+              </a:buClr>
+              <a:buFont typeface="Arial"/>
+              <a:buChar char="•"/>
+            </a:pPr>
+            <a:r>
+              <a:rPr sz="2300">
+                <a:solidFill>
+                  <a:srgbClr val="1E293B"/>
+                </a:solidFill>
+                <a:latin typeface="Calibri"/>
+              </a:rPr>
+              <a:t>TB: nhan đề – đề từ; cấu tứ tương phản qua 4 khổ; hệ thống hình ảnh, thi liệu.</a:t>
+            </a:r>
+          </a:p>
+          <a:p>
+            <a:pPr algn="l" marL="365760" indent="-365760">
+              <a:spcAft>
+                <a:spcPts val="800"/>
+              </a:spcAft>
+              <a:buClr>
+                <a:srgbClr val="1E40AF"/>
+              </a:buClr>
+              <a:buFont typeface="Arial"/>
+              <a:buChar char="•"/>
+            </a:pPr>
+            <a:r>
+              <a:rPr sz="2300">
+                <a:solidFill>
+                  <a:srgbClr val="1E293B"/>
+                </a:solidFill>
+                <a:latin typeface="Calibri"/>
+              </a:rPr>
+              <a:t>Yếu tố tượng trưng, ngôn ngữ phá cách; đánh giá.</a:t>
+            </a:r>
+          </a:p>
+          <a:p>
+            <a:pPr algn="l" marL="365760" indent="-365760">
+              <a:spcAft>
+                <a:spcPts val="800"/>
+              </a:spcAft>
+              <a:buClr>
+                <a:srgbClr val="1E40AF"/>
+              </a:buClr>
+              <a:buFont typeface="Arial"/>
+              <a:buChar char="•"/>
+            </a:pPr>
+            <a:r>
+              <a:rPr sz="2300">
+                <a:solidFill>
+                  <a:srgbClr val="1E293B"/>
+                </a:solidFill>
+                <a:latin typeface="Calibri"/>
+              </a:rPr>
+              <a:t>KB: khẳng định giá trị.</a:t>
+            </a:r>
+          </a:p>
+        </p:txBody>
+      </p:sp>
+      <p:sp>
+        <p:nvSpPr>
+          <p:cNvPr id="8" name="Rounded Rectangle 7"/>
+          <p:cNvSpPr/>
+          <p:nvPr/>
+        </p:nvSpPr>
+        <p:spPr>
+          <a:xfrm>
+            <a:off x="731520" y="5074920"/>
+            <a:ext cx="10789920" cy="731520"/>
+          </a:xfrm>
+          <a:prstGeom prst="roundRect">
+            <a:avLst>
+              <a:gd name="adj" fmla="val 8000"/>
+            </a:avLst>
+          </a:prstGeom>
+          <a:solidFill>
+            <a:srgbClr val="FEF2F2"/>
+          </a:solidFill>
+          <a:ln w="19050">
+            <a:solidFill>
+              <a:srgbClr val="991B1B"/>
+            </a:solidFill>
+          </a:ln>
+          <a:effectLst/>
+        </p:spPr>
+        <p:style>
+          <a:lnRef idx="1">
+            <a:schemeClr val="accent1"/>
+          </a:lnRef>
+          <a:fillRef idx="3">
+            <a:schemeClr val="accent1"/>
+          </a:fillRef>
+          <a:effectRef idx="2">
+            <a:schemeClr val="accent1"/>
+          </a:effectRef>
+          <a:fontRef idx="minor">
+            <a:schemeClr val="lt1"/>
+          </a:fontRef>
+        </p:style>
+        <p:txBody>
+          <a:bodyPr rtlCol="0" anchor="ctr"/>
+          <a:lstStyle/>
+          <a:p>
+            <a:pPr algn="ctr"/>
+          </a:p>
+        </p:txBody>
+      </p:sp>
+      <p:sp>
+        <p:nvSpPr>
+          <p:cNvPr id="9" name="TextBox 8"/>
+          <p:cNvSpPr txBox="1"/>
+          <p:nvPr/>
+        </p:nvSpPr>
+        <p:spPr>
+          <a:xfrm>
+            <a:off x="914400" y="5074920"/>
+            <a:ext cx="10424160" cy="731520"/>
+          </a:xfrm>
+          <a:prstGeom prst="rect">
+            <a:avLst/>
+          </a:prstGeom>
+          <a:noFill/>
+        </p:spPr>
+        <p:txBody>
+          <a:bodyPr wrap="square" anchor="ctr" lIns="45720" rIns="45720">
+            <a:spAutoFit/>
+          </a:bodyPr>
+          <a:lstStyle/>
+          <a:p>
+            <a:pPr algn="l">
+              <a:spcAft>
+                <a:spcPts val="400"/>
+              </a:spcAft>
+            </a:pPr>
+            <a:r>
+              <a:rPr sz="2400" b="1">
+                <a:solidFill>
+                  <a:srgbClr val="991B1B"/>
+                </a:solidFill>
+                <a:latin typeface="Calibri"/>
+              </a:rPr>
+              <a:t>Gắn cấu tứ với hệ thống hình ảnh.</a:t>
+            </a:r>
+          </a:p>
+        </p:txBody>
+      </p:sp>
+    </p:spTree>
+  </p:cSld>
+  <p:clrMapOvr>
+    <a:masterClrMapping/>
+  </p:clrMapOvr>
+</p:sld>
+</file>
+
+<file path=ppt/slides/slide32.xml><?xml version="1.0" encoding="utf-8"?>
+<p:sld xmlns:a="http://schemas.openxmlformats.org/drawingml/2006/main" xmlns:p="http://schemas.openxmlformats.org/presentationml/2006/main" xmlns:r="http://schemas.openxmlformats.org/officeDocument/2006/relationships">
+  <p:cSld>
+    <p:bg>
+      <p:bgPr>
+        <a:solidFill>
+          <a:srgbClr val="FFFFFF"/>
+        </a:solidFill>
+        <a:effectLst/>
+      </p:bgPr>
+    </p:bg>
+    <p:spTree>
+      <p:nvGrpSpPr>
+        <p:cNvPr id="1" name=""/>
+        <p:cNvGrpSpPr/>
+        <p:nvPr/>
+      </p:nvGrpSpPr>
+      <p:grpSpPr/>
+      <p:sp>
+        <p:nvSpPr>
+          <p:cNvPr id="2" name="Rectangle 1"/>
+          <p:cNvSpPr/>
+          <p:nvPr/>
+        </p:nvSpPr>
+        <p:spPr>
+          <a:xfrm>
+            <a:off x="457200" y="384048"/>
+            <a:ext cx="109728" cy="658368"/>
+          </a:xfrm>
+          <a:prstGeom prst="rect">
+            <a:avLst/>
+          </a:prstGeom>
+          <a:solidFill>
+            <a:srgbClr val="1E40AF"/>
+          </a:solidFill>
+          <a:ln>
+            <a:noFill/>
+          </a:ln>
+          <a:effectLst/>
+        </p:spPr>
+        <p:style>
+          <a:lnRef idx="1">
+            <a:schemeClr val="accent1"/>
+          </a:lnRef>
+          <a:fillRef idx="3">
+            <a:schemeClr val="accent1"/>
+          </a:fillRef>
+          <a:effectRef idx="2">
+            <a:schemeClr val="accent1"/>
+          </a:effectRef>
+          <a:fontRef idx="minor">
+            <a:schemeClr val="lt1"/>
+          </a:fontRef>
+        </p:style>
+        <p:txBody>
+          <a:bodyPr rtlCol="0" anchor="ctr"/>
+          <a:lstStyle/>
+          <a:p>
+            <a:pPr algn="ctr"/>
+          </a:p>
+        </p:txBody>
+      </p:sp>
+      <p:sp>
+        <p:nvSpPr>
+          <p:cNvPr id="3" name="Rounded Rectangle 2"/>
+          <p:cNvSpPr/>
+          <p:nvPr/>
+        </p:nvSpPr>
+        <p:spPr>
+          <a:xfrm>
+            <a:off x="10097719" y="457200"/>
+            <a:ext cx="1545336" cy="457200"/>
+          </a:xfrm>
+          <a:prstGeom prst="roundRect">
+            <a:avLst/>
+          </a:prstGeom>
+          <a:solidFill>
+            <a:srgbClr val="166534"/>
+          </a:solidFill>
+          <a:ln>
+            <a:noFill/>
+          </a:ln>
+          <a:effectLst/>
+        </p:spPr>
+        <p:style>
+          <a:lnRef idx="1">
+            <a:schemeClr val="accent1"/>
+          </a:lnRef>
+          <a:fillRef idx="3">
+            <a:schemeClr val="accent1"/>
+          </a:fillRef>
+          <a:effectRef idx="2">
+            <a:schemeClr val="accent1"/>
+          </a:effectRef>
+          <a:fontRef idx="minor">
+            <a:schemeClr val="lt1"/>
+          </a:fontRef>
+        </p:style>
+        <p:txBody>
+          <a:bodyPr rtlCol="0" anchor="ctr" wrap="none" tIns="0" bIns="0"/>
+          <a:lstStyle/>
+          <a:p>
+            <a:pPr algn="ctr"/>
+            <a:r>
+              <a:rPr sz="1400" b="1">
+                <a:solidFill>
+                  <a:srgbClr val="FFFFFF"/>
+                </a:solidFill>
+                <a:latin typeface="Arial"/>
+              </a:rPr>
+              <a:t>CỦNG CỐ</a:t>
+            </a:r>
+          </a:p>
+        </p:txBody>
+      </p:sp>
+      <p:sp>
+        <p:nvSpPr>
+          <p:cNvPr id="4" name="TextBox 3"/>
+          <p:cNvSpPr txBox="1"/>
+          <p:nvPr/>
+        </p:nvSpPr>
+        <p:spPr>
+          <a:xfrm>
+            <a:off x="731520" y="274320"/>
+            <a:ext cx="9427464" cy="868680"/>
+          </a:xfrm>
+          <a:prstGeom prst="rect">
+            <a:avLst/>
+          </a:prstGeom>
+          <a:noFill/>
+        </p:spPr>
+        <p:txBody>
+          <a:bodyPr wrap="square" anchor="ctr">
+            <a:spAutoFit/>
+          </a:bodyPr>
+          <a:lstStyle/>
+          <a:p>
+            <a:r>
+              <a:rPr sz="3600" b="1">
+                <a:solidFill>
+                  <a:srgbClr val="1E40AF"/>
+                </a:solidFill>
+                <a:latin typeface="Arial"/>
+              </a:rPr>
+              <a:t>SƠ ĐỒ TƯ DUY</a:t>
+            </a:r>
+          </a:p>
+        </p:txBody>
+      </p:sp>
+      <p:sp>
+        <p:nvSpPr>
+          <p:cNvPr id="5" name="Rectangle 4"/>
+          <p:cNvSpPr/>
+          <p:nvPr/>
+        </p:nvSpPr>
+        <p:spPr>
+          <a:xfrm>
+            <a:off x="457200" y="1207008"/>
+            <a:ext cx="11274552" cy="22000"/>
+          </a:xfrm>
+          <a:prstGeom prst="rect">
+            <a:avLst/>
+          </a:prstGeom>
+          <a:solidFill>
+            <a:srgbClr val="E2E8F0"/>
+          </a:solidFill>
+          <a:ln>
+            <a:noFill/>
+          </a:ln>
+          <a:effectLst/>
+        </p:spPr>
+        <p:style>
+          <a:lnRef idx="1">
+            <a:schemeClr val="accent1"/>
+          </a:lnRef>
+          <a:fillRef idx="3">
+            <a:schemeClr val="accent1"/>
+          </a:fillRef>
+          <a:effectRef idx="2">
+            <a:schemeClr val="accent1"/>
+          </a:effectRef>
+          <a:fontRef idx="minor">
+            <a:schemeClr val="lt1"/>
+          </a:fontRef>
+        </p:style>
+        <p:txBody>
+          <a:bodyPr rtlCol="0" anchor="ctr"/>
+          <a:lstStyle/>
+          <a:p>
+            <a:pPr algn="ctr"/>
+          </a:p>
+        </p:txBody>
+      </p:sp>
+      <p:sp>
+        <p:nvSpPr>
+          <p:cNvPr id="6" name="TextBox 5"/>
+          <p:cNvSpPr txBox="1"/>
+          <p:nvPr/>
+        </p:nvSpPr>
+        <p:spPr>
+          <a:xfrm>
+            <a:off x="457200" y="6355080"/>
+            <a:ext cx="11274552" cy="365760"/>
+          </a:xfrm>
+          <a:prstGeom prst="rect">
+            <a:avLst/>
+          </a:prstGeom>
+          <a:noFill/>
+        </p:spPr>
+        <p:txBody>
+          <a:bodyPr wrap="none">
+            <a:spAutoFit/>
+          </a:bodyPr>
+          <a:lstStyle/>
+          <a:p>
+            <a:pPr algn="r"/>
+            <a:r>
+              <a:rPr sz="1200">
+                <a:solidFill>
+                  <a:srgbClr val="64748B"/>
+                </a:solidFill>
+                <a:latin typeface="Calibri"/>
+              </a:rPr>
+              <a:t>Ngữ văn 11 · Bài 2: Cấu Tứ Và Hình Ảnh Trong Thơ Trữ Tình          32</a:t>
+            </a:r>
+          </a:p>
+        </p:txBody>
+      </p:sp>
+      <p:pic>
+        <p:nvPicPr>
+          <p:cNvPr id="7" name="Picture 6" descr="SoDoTuDuy_NGUVAN11_Bai2_CauTuVaHinhAnhTrongThoTruTinh_T12-22.png"/>
+          <p:cNvPicPr>
+            <a:picLocks noChangeAspect="1"/>
+          </p:cNvPicPr>
+          <p:nvPr/>
+        </p:nvPicPr>
+        <p:blipFill>
+          <a:blip r:embed="rId2"/>
+          <a:stretch>
+            <a:fillRect/>
+          </a:stretch>
+        </p:blipFill>
+        <p:spPr>
+          <a:xfrm>
+            <a:off x="1788855" y="1371600"/>
+            <a:ext cx="8675250" cy="4846320"/>
+          </a:xfrm>
+          <a:prstGeom prst="rect">
+            <a:avLst/>
+          </a:prstGeom>
+        </p:spPr>
+      </p:pic>
+    </p:spTree>
+  </p:cSld>
+  <p:clrMapOvr>
+    <a:masterClrMapping/>
+  </p:clrMapOvr>
+</p:sld>
+</file>
+
+<file path=ppt/slides/slide33.xml><?xml version="1.0" encoding="utf-8"?>
+<p:sld xmlns:a="http://schemas.openxmlformats.org/drawingml/2006/main" xmlns:p="http://schemas.openxmlformats.org/presentationml/2006/main" xmlns:r="http://schemas.openxmlformats.org/officeDocument/2006/relationships">
+  <p:cSld>
+    <p:bg>
+      <p:bgPr>
+        <a:solidFill>
+          <a:srgbClr val="FFFFFF"/>
+        </a:solidFill>
+        <a:effectLst/>
+      </p:bgPr>
+    </p:bg>
+    <p:spTree>
+      <p:nvGrpSpPr>
+        <p:cNvPr id="1" name=""/>
+        <p:cNvGrpSpPr/>
+        <p:nvPr/>
+      </p:nvGrpSpPr>
+      <p:grpSpPr/>
+      <p:sp>
+        <p:nvSpPr>
+          <p:cNvPr id="2" name="Rectangle 1"/>
+          <p:cNvSpPr/>
+          <p:nvPr/>
+        </p:nvSpPr>
+        <p:spPr>
+          <a:xfrm>
+            <a:off x="457200" y="384048"/>
+            <a:ext cx="109728" cy="658368"/>
+          </a:xfrm>
+          <a:prstGeom prst="rect">
+            <a:avLst/>
+          </a:prstGeom>
+          <a:solidFill>
+            <a:srgbClr val="1E40AF"/>
+          </a:solidFill>
+          <a:ln>
+            <a:noFill/>
+          </a:ln>
+          <a:effectLst/>
+        </p:spPr>
+        <p:style>
+          <a:lnRef idx="1">
+            <a:schemeClr val="accent1"/>
+          </a:lnRef>
+          <a:fillRef idx="3">
+            <a:schemeClr val="accent1"/>
+          </a:fillRef>
+          <a:effectRef idx="2">
+            <a:schemeClr val="accent1"/>
+          </a:effectRef>
+          <a:fontRef idx="minor">
+            <a:schemeClr val="lt1"/>
+          </a:fontRef>
+        </p:style>
+        <p:txBody>
+          <a:bodyPr rtlCol="0" anchor="ctr"/>
+          <a:lstStyle/>
+          <a:p>
+            <a:pPr algn="ctr"/>
+          </a:p>
+        </p:txBody>
+      </p:sp>
+      <p:sp>
+        <p:nvSpPr>
+          <p:cNvPr id="3" name="Rounded Rectangle 2"/>
+          <p:cNvSpPr/>
+          <p:nvPr/>
+        </p:nvSpPr>
+        <p:spPr>
+          <a:xfrm>
+            <a:off x="10097719" y="457200"/>
+            <a:ext cx="1545336" cy="457200"/>
+          </a:xfrm>
+          <a:prstGeom prst="roundRect">
+            <a:avLst/>
+          </a:prstGeom>
+          <a:solidFill>
+            <a:srgbClr val="991B1B"/>
+          </a:solidFill>
+          <a:ln>
+            <a:noFill/>
+          </a:ln>
+          <a:effectLst/>
+        </p:spPr>
+        <p:style>
+          <a:lnRef idx="1">
+            <a:schemeClr val="accent1"/>
+          </a:lnRef>
+          <a:fillRef idx="3">
+            <a:schemeClr val="accent1"/>
+          </a:fillRef>
+          <a:effectRef idx="2">
+            <a:schemeClr val="accent1"/>
+          </a:effectRef>
+          <a:fontRef idx="minor">
+            <a:schemeClr val="lt1"/>
+          </a:fontRef>
+        </p:style>
+        <p:txBody>
+          <a:bodyPr rtlCol="0" anchor="ctr" wrap="none" tIns="0" bIns="0"/>
+          <a:lstStyle/>
+          <a:p>
+            <a:pPr algn="ctr"/>
+            <a:r>
+              <a:rPr sz="1400" b="1">
+                <a:solidFill>
+                  <a:srgbClr val="FFFFFF"/>
+                </a:solidFill>
+                <a:latin typeface="Arial"/>
+              </a:rPr>
+              <a:t>CỦNG CỐ</a:t>
+            </a:r>
+          </a:p>
+        </p:txBody>
+      </p:sp>
+      <p:sp>
+        <p:nvSpPr>
+          <p:cNvPr id="4" name="TextBox 3"/>
+          <p:cNvSpPr txBox="1"/>
+          <p:nvPr/>
+        </p:nvSpPr>
+        <p:spPr>
+          <a:xfrm>
+            <a:off x="731520" y="274320"/>
+            <a:ext cx="9427464" cy="868680"/>
+          </a:xfrm>
+          <a:prstGeom prst="rect">
+            <a:avLst/>
+          </a:prstGeom>
+          <a:noFill/>
+        </p:spPr>
+        <p:txBody>
+          <a:bodyPr wrap="square" anchor="ctr">
+            <a:spAutoFit/>
+          </a:bodyPr>
+          <a:lstStyle/>
+          <a:p>
+            <a:r>
+              <a:rPr sz="3600" b="1">
+                <a:solidFill>
+                  <a:srgbClr val="1E40AF"/>
+                </a:solidFill>
+                <a:latin typeface="Arial"/>
+              </a:rPr>
+              <a:t>BÀI TẬP CỦA BẠN</a:t>
+            </a:r>
+          </a:p>
+        </p:txBody>
+      </p:sp>
+      <p:sp>
+        <p:nvSpPr>
+          <p:cNvPr id="5" name="Rectangle 4"/>
+          <p:cNvSpPr/>
+          <p:nvPr/>
+        </p:nvSpPr>
+        <p:spPr>
+          <a:xfrm>
+            <a:off x="457200" y="1207008"/>
+            <a:ext cx="11274552" cy="22000"/>
+          </a:xfrm>
+          <a:prstGeom prst="rect">
+            <a:avLst/>
+          </a:prstGeom>
+          <a:solidFill>
+            <a:srgbClr val="E2E8F0"/>
+          </a:solidFill>
+          <a:ln>
+            <a:noFill/>
+          </a:ln>
+          <a:effectLst/>
+        </p:spPr>
+        <p:style>
+          <a:lnRef idx="1">
+            <a:schemeClr val="accent1"/>
+          </a:lnRef>
+          <a:fillRef idx="3">
+            <a:schemeClr val="accent1"/>
+          </a:fillRef>
+          <a:effectRef idx="2">
+            <a:schemeClr val="accent1"/>
+          </a:effectRef>
+          <a:fontRef idx="minor">
+            <a:schemeClr val="lt1"/>
+          </a:fontRef>
+        </p:style>
+        <p:txBody>
+          <a:bodyPr rtlCol="0" anchor="ctr"/>
+          <a:lstStyle/>
+          <a:p>
+            <a:pPr algn="ctr"/>
+          </a:p>
+        </p:txBody>
+      </p:sp>
+      <p:sp>
+        <p:nvSpPr>
+          <p:cNvPr id="6" name="TextBox 5"/>
+          <p:cNvSpPr txBox="1"/>
+          <p:nvPr/>
+        </p:nvSpPr>
+        <p:spPr>
+          <a:xfrm>
+            <a:off x="457200" y="6355080"/>
+            <a:ext cx="11274552" cy="365760"/>
+          </a:xfrm>
+          <a:prstGeom prst="rect">
+            <a:avLst/>
+          </a:prstGeom>
+          <a:noFill/>
+        </p:spPr>
+        <p:txBody>
+          <a:bodyPr wrap="none">
+            <a:spAutoFit/>
+          </a:bodyPr>
+          <a:lstStyle/>
+          <a:p>
+            <a:pPr algn="r"/>
+            <a:r>
+              <a:rPr sz="1200">
+                <a:solidFill>
+                  <a:srgbClr val="64748B"/>
+                </a:solidFill>
+                <a:latin typeface="Calibri"/>
+              </a:rPr>
+              <a:t>Ngữ văn 11 · Bài 2: Cấu Tứ Và Hình Ảnh Trong Thơ Trữ Tình          33</a:t>
             </a:r>
           </a:p>
         </p:txBody>

</xml_diff>